<commit_message>
Use Vista node and core counts
</commit_message>
<xml_diff>
--- a/slides/hpc-office-hours.pptx
+++ b/slides/hpc-office-hours.pptx
@@ -8814,7 +8814,7 @@
                 </a:solidFill>
                 <a:latin typeface="Arial"/>
               </a:rPr>
-              <a:t>8</a:t>
+              <a:t>1</a:t>
             </a:r>
           </a:p>
         </p:txBody>
@@ -8853,7 +8853,7 @@
                 </a:solidFill>
                 <a:latin typeface="Georgia"/>
               </a:rPr>
-              <a:t>cores in your laptop</a:t>
+              <a:t>worker</a:t>
             </a:r>
           </a:p>
         </p:txBody>
@@ -9092,7 +9092,7 @@
                 </a:solidFill>
                 <a:latin typeface="Georgia"/>
               </a:rPr>
-              <a:t>cores in one Vista CPU node</a:t>
+              <a:t>cores per CPU node (72 per GPU node)</a:t>
             </a:r>
           </a:p>
         </p:txBody>
@@ -9214,7 +9214,7 @@
                 </a:solidFill>
                 <a:latin typeface="Arial"/>
               </a:rPr>
-              <a:t>SUPERCOMPUTER</a:t>
+              <a:t>VISTA</a:t>
             </a:r>
           </a:p>
         </p:txBody>
@@ -9253,7 +9253,7 @@
                 </a:solidFill>
                 <a:latin typeface="Georgia"/>
               </a:rPr>
-              <a:t>Many nodes wired together</a:t>
+              <a:t>All the nodes wired together</a:t>
             </a:r>
           </a:p>
         </p:txBody>
@@ -9292,7 +9292,7 @@
                 </a:solidFill>
                 <a:latin typeface="Arial"/>
               </a:rPr>
-              <a:t>100s</a:t>
+              <a:t>856</a:t>
             </a:r>
           </a:p>
         </p:txBody>
@@ -9331,7 +9331,7 @@
                 </a:solidFill>
                 <a:latin typeface="Georgia"/>
               </a:rPr>
-              <a:t>of nodes in Vista alone</a:t>
+              <a:t>nodes: 256 CPU + 600 GPU</a:t>
             </a:r>
           </a:p>
         </p:txBody>
@@ -9458,7 +9458,7 @@
                 </a:solidFill>
                 <a:latin typeface="Arial"/>
               </a:rPr>
-              <a:t>THINK OF IT AS  </a:t>
+              <a:t>VISTA IN TOTAL  </a:t>
             </a:r>
             <a:r>
               <a:rPr sz="2000" b="0">
@@ -9467,7 +9467,7 @@
                 </a:solidFill>
                 <a:latin typeface="Georgia"/>
               </a:rPr>
-              <a:t>A core is one worker. A node is a building of workers. The supercomputer is the campus.</a:t>
+              <a:t>856 nodes and 80,064 cores working together.</a:t>
             </a:r>
           </a:p>
         </p:txBody>

</xml_diff>

<commit_message>
Expand what's next slide; add let's connect slide
</commit_message>
<xml_diff>
--- a/slides/hpc-office-hours.pptx
+++ b/slides/hpc-office-hours.pptx
@@ -17,6 +17,7 @@
     <p:sldId id="265" r:id="rId16"/>
     <p:sldId id="266" r:id="rId17"/>
     <p:sldId id="267" r:id="rId18"/>
+    <p:sldId id="268" r:id="rId19"/>
   </p:sldIdLst>
   <p:sldSz cx="12191695" cy="6858000" type="screen4x3"/>
   <p:notesSz cx="6858000" cy="9144000"/>
@@ -4923,8 +4924,8 @@
         </p:nvSpPr>
         <p:spPr>
           <a:xfrm>
-            <a:off x="640080" y="502920"/>
-            <a:ext cx="10881360" cy="822960"/>
+            <a:off x="640080" y="411480"/>
+            <a:ext cx="10881360" cy="731520"/>
           </a:xfrm>
           <a:prstGeom prst="rect">
             <a:avLst/>
@@ -4943,13 +4944,13 @@
               </a:lnSpc>
             </a:pPr>
             <a:r>
-              <a:rPr sz="3400" b="1">
+              <a:rPr sz="3000" b="1">
                 <a:solidFill>
                   <a:srgbClr val="FFFFFF"/>
                 </a:solidFill>
                 <a:latin typeface="Arial"/>
               </a:rPr>
-              <a:t>WHAT'S NEXT</a:t>
+              <a:t>WHAT'S NEXT: REAL DATA FOR YOUR OPIL WORK</a:t>
             </a:r>
           </a:p>
         </p:txBody>
@@ -4962,7 +4963,7 @@
         </p:nvSpPr>
         <p:spPr>
           <a:xfrm>
-            <a:off x="640080" y="1344168"/>
+            <a:off x="640080" y="1143000"/>
             <a:ext cx="1005840" cy="73152"/>
           </a:xfrm>
           <a:prstGeom prst="rect">
@@ -5000,14 +5001,62 @@
       </p:sp>
       <p:sp>
         <p:nvSpPr>
-          <p:cNvPr id="4" name="Rectangle 3"/>
+          <p:cNvPr id="4" name="TextBox 3"/>
+          <p:cNvSpPr txBox="1"/>
+          <p:nvPr/>
+        </p:nvSpPr>
+        <p:spPr>
+          <a:xfrm>
+            <a:off x="640080" y="1371600"/>
+            <a:ext cx="10881360" cy="548640"/>
+          </a:xfrm>
+          <a:prstGeom prst="rect">
+            <a:avLst/>
+          </a:prstGeom>
+          <a:noFill/>
+        </p:spPr>
+        <p:txBody>
+          <a:bodyPr wrap="square" anchor="t" lIns="0" rIns="0" tIns="0" bIns="0">
+            <a:spAutoFit/>
+          </a:bodyPr>
+          <a:lstStyle/>
+          <a:p>
+            <a:pPr algn="l">
+              <a:lnSpc>
+                <a:spcPct val="110000"/>
+              </a:lnSpc>
+            </a:pPr>
+            <a:r>
+              <a:rPr sz="1700" b="1">
+                <a:solidFill>
+                  <a:srgbClr val="C1A231"/>
+                </a:solidFill>
+                <a:latin typeface="Georgia"/>
+              </a:rPr>
+              <a:t>The data: </a:t>
+            </a:r>
+            <a:r>
+              <a:rPr sz="1700" b="0">
+                <a:solidFill>
+                  <a:srgbClr val="FFFFFF"/>
+                </a:solidFill>
+                <a:latin typeface="Georgia"/>
+              </a:rPr>
+              <a:t>the CFPB Consumer Complaint Database. About 10 million real complaints about money transfers, prepaid cards, and digital payments, too big for a laptop.</a:t>
+            </a:r>
+          </a:p>
+        </p:txBody>
+      </p:sp>
+      <p:sp>
+        <p:nvSpPr>
+          <p:cNvPr id="5" name="Rectangle 4"/>
           <p:cNvSpPr/>
           <p:nvPr/>
         </p:nvSpPr>
         <p:spPr>
           <a:xfrm>
-            <a:off x="640080" y="1828800"/>
-            <a:ext cx="5330952" cy="2011680"/>
+            <a:off x="640080" y="2148840"/>
+            <a:ext cx="5330952" cy="2788920"/>
           </a:xfrm>
           <a:prstGeom prst="rect">
             <a:avLst/>
@@ -5044,14 +5093,14 @@
       </p:sp>
       <p:sp>
         <p:nvSpPr>
-          <p:cNvPr id="5" name="Rectangle 4"/>
+          <p:cNvPr id="6" name="Rectangle 5"/>
           <p:cNvSpPr/>
           <p:nvPr/>
         </p:nvSpPr>
         <p:spPr>
           <a:xfrm>
-            <a:off x="640080" y="1828800"/>
-            <a:ext cx="109728" cy="2011680"/>
+            <a:off x="640080" y="2148840"/>
+            <a:ext cx="109728" cy="2788920"/>
           </a:xfrm>
           <a:prstGeom prst="rect">
             <a:avLst/>
@@ -5088,14 +5137,14 @@
       </p:sp>
       <p:sp>
         <p:nvSpPr>
-          <p:cNvPr id="6" name="TextBox 5"/>
+          <p:cNvPr id="7" name="TextBox 6"/>
           <p:cNvSpPr txBox="1"/>
           <p:nvPr/>
         </p:nvSpPr>
         <p:spPr>
           <a:xfrm>
-            <a:off x="1051560" y="2103120"/>
-            <a:ext cx="4572000" cy="548640"/>
+            <a:off x="1005840" y="2286000"/>
+            <a:ext cx="4754880" cy="457200"/>
           </a:xfrm>
           <a:prstGeom prst="rect">
             <a:avLst/>
@@ -5114,27 +5163,36 @@
               </a:lnSpc>
             </a:pPr>
             <a:r>
-              <a:rPr sz="3000" b="1">
+              <a:rPr sz="2000" b="1">
                 <a:solidFill>
                   <a:srgbClr val="840028"/>
                 </a:solidFill>
                 <a:latin typeface="Arial"/>
               </a:rPr>
-              <a:t>OCT 14</a:t>
-            </a:r>
-          </a:p>
-        </p:txBody>
-      </p:sp>
-      <p:sp>
-        <p:nvSpPr>
-          <p:cNvPr id="7" name="TextBox 6"/>
+              <a:t>OCT 14   </a:t>
+            </a:r>
+            <a:r>
+              <a:rPr sz="2000" b="1">
+                <a:solidFill>
+                  <a:srgbClr val="000000"/>
+                </a:solidFill>
+                <a:latin typeface="Arial"/>
+              </a:rPr>
+              <a:t>WHAT THE DATA SAYS</a:t>
+            </a:r>
+          </a:p>
+        </p:txBody>
+      </p:sp>
+      <p:sp>
+        <p:nvSpPr>
+          <p:cNvPr id="8" name="TextBox 7"/>
           <p:cNvSpPr txBox="1"/>
           <p:nvPr/>
         </p:nvSpPr>
         <p:spPr>
           <a:xfrm>
-            <a:off x="1051560" y="2788920"/>
-            <a:ext cx="4754880" cy="822960"/>
+            <a:off x="1005840" y="2834640"/>
+            <a:ext cx="4754880" cy="1097280"/>
           </a:xfrm>
           <a:prstGeom prst="rect">
             <a:avLst/>
@@ -5153,27 +5211,75 @@
               </a:lnSpc>
             </a:pPr>
             <a:r>
-              <a:rPr sz="2400" b="0">
+              <a:rPr sz="1500" b="0">
+                <a:solidFill>
+                  <a:srgbClr val="4A4A4A"/>
+                </a:solidFill>
+                <a:latin typeface="Georgia"/>
+              </a:rPr>
+              <a:t>Count complaints by product, company, state, and year. Each team edits one cell for its own sector and state.</a:t>
+            </a:r>
+          </a:p>
+        </p:txBody>
+      </p:sp>
+      <p:sp>
+        <p:nvSpPr>
+          <p:cNvPr id="9" name="TextBox 8"/>
+          <p:cNvSpPr txBox="1"/>
+          <p:nvPr/>
+        </p:nvSpPr>
+        <p:spPr>
+          <a:xfrm>
+            <a:off x="1005840" y="3931920"/>
+            <a:ext cx="4754880" cy="914400"/>
+          </a:xfrm>
+          <a:prstGeom prst="rect">
+            <a:avLst/>
+          </a:prstGeom>
+          <a:noFill/>
+        </p:spPr>
+        <p:txBody>
+          <a:bodyPr wrap="square" anchor="t" lIns="0" rIns="0" tIns="0" bIns="0">
+            <a:spAutoFit/>
+          </a:bodyPr>
+          <a:lstStyle/>
+          <a:p>
+            <a:pPr algn="l">
+              <a:lnSpc>
+                <a:spcPct val="110000"/>
+              </a:lnSpc>
+            </a:pPr>
+            <a:r>
+              <a:rPr sz="1500" b="1">
+                <a:solidFill>
+                  <a:srgbClr val="840028"/>
+                </a:solidFill>
+                <a:latin typeface="Georgia"/>
+              </a:rPr>
+              <a:t>You leave with: </a:t>
+            </a:r>
+            <a:r>
+              <a:rPr sz="1500" b="0">
                 <a:solidFill>
                   <a:srgbClr val="000000"/>
                 </a:solidFill>
                 <a:latin typeface="Georgia"/>
               </a:rPr>
-              <a:t>What the Data Says</a:t>
-            </a:r>
-          </a:p>
-        </p:txBody>
-      </p:sp>
-      <p:sp>
-        <p:nvSpPr>
-          <p:cNvPr id="8" name="Rectangle 7"/>
+              <a:t>Three numbers for your Monetization Canvas (due Oct 23).</a:t>
+            </a:r>
+          </a:p>
+        </p:txBody>
+      </p:sp>
+      <p:sp>
+        <p:nvSpPr>
+          <p:cNvPr id="10" name="Rectangle 9"/>
           <p:cNvSpPr/>
           <p:nvPr/>
         </p:nvSpPr>
         <p:spPr>
           <a:xfrm>
-            <a:off x="6217920" y="1828800"/>
-            <a:ext cx="5330952" cy="2011680"/>
+            <a:off x="6217920" y="2148840"/>
+            <a:ext cx="5330952" cy="2788920"/>
           </a:xfrm>
           <a:prstGeom prst="rect">
             <a:avLst/>
@@ -5210,14 +5316,14 @@
       </p:sp>
       <p:sp>
         <p:nvSpPr>
-          <p:cNvPr id="9" name="Rectangle 8"/>
+          <p:cNvPr id="11" name="Rectangle 10"/>
           <p:cNvSpPr/>
           <p:nvPr/>
         </p:nvSpPr>
         <p:spPr>
           <a:xfrm>
-            <a:off x="6217920" y="1828800"/>
-            <a:ext cx="109728" cy="2011680"/>
+            <a:off x="6217920" y="2148840"/>
+            <a:ext cx="109728" cy="2788920"/>
           </a:xfrm>
           <a:prstGeom prst="rect">
             <a:avLst/>
@@ -5254,14 +5360,14 @@
       </p:sp>
       <p:sp>
         <p:nvSpPr>
-          <p:cNvPr id="10" name="TextBox 9"/>
+          <p:cNvPr id="12" name="TextBox 11"/>
           <p:cNvSpPr txBox="1"/>
           <p:nvPr/>
         </p:nvSpPr>
         <p:spPr>
           <a:xfrm>
-            <a:off x="6629400" y="2103120"/>
-            <a:ext cx="4572000" cy="548640"/>
+            <a:off x="6583680" y="2286000"/>
+            <a:ext cx="4754880" cy="457200"/>
           </a:xfrm>
           <a:prstGeom prst="rect">
             <a:avLst/>
@@ -5280,27 +5386,36 @@
               </a:lnSpc>
             </a:pPr>
             <a:r>
-              <a:rPr sz="3000" b="1">
+              <a:rPr sz="2000" b="1">
                 <a:solidFill>
                   <a:srgbClr val="840028"/>
                 </a:solidFill>
                 <a:latin typeface="Arial"/>
               </a:rPr>
-              <a:t>NOV 4</a:t>
-            </a:r>
-          </a:p>
-        </p:txBody>
-      </p:sp>
-      <p:sp>
-        <p:nvSpPr>
-          <p:cNvPr id="11" name="TextBox 10"/>
+              <a:t>NOV 4   </a:t>
+            </a:r>
+            <a:r>
+              <a:rPr sz="2000" b="1">
+                <a:solidFill>
+                  <a:srgbClr val="000000"/>
+                </a:solidFill>
+                <a:latin typeface="Arial"/>
+              </a:rPr>
+              <a:t>FINDING THE PAIN POINT</a:t>
+            </a:r>
+          </a:p>
+        </p:txBody>
+      </p:sp>
+      <p:sp>
+        <p:nvSpPr>
+          <p:cNvPr id="13" name="TextBox 12"/>
           <p:cNvSpPr txBox="1"/>
           <p:nvPr/>
         </p:nvSpPr>
         <p:spPr>
           <a:xfrm>
-            <a:off x="6629400" y="2788920"/>
-            <a:ext cx="4754880" cy="822960"/>
+            <a:off x="6583680" y="2834640"/>
+            <a:ext cx="4754880" cy="1097280"/>
           </a:xfrm>
           <a:prstGeom prst="rect">
             <a:avLst/>
@@ -5319,27 +5434,27 @@
               </a:lnSpc>
             </a:pPr>
             <a:r>
-              <a:rPr sz="2400" b="0">
-                <a:solidFill>
-                  <a:srgbClr val="000000"/>
+              <a:rPr sz="1500" b="0">
+                <a:solidFill>
+                  <a:srgbClr val="4A4A4A"/>
                 </a:solidFill>
                 <a:latin typeface="Georgia"/>
               </a:rPr>
-              <a:t>Finding the Pain Point</a:t>
-            </a:r>
-          </a:p>
-        </p:txBody>
-      </p:sp>
-      <p:sp>
-        <p:nvSpPr>
-          <p:cNvPr id="12" name="TextBox 11"/>
+              <a:t>Read the complaint narratives at scale and pull the theme closest to your team's business problem.</a:t>
+            </a:r>
+          </a:p>
+        </p:txBody>
+      </p:sp>
+      <p:sp>
+        <p:nvSpPr>
+          <p:cNvPr id="14" name="TextBox 13"/>
           <p:cNvSpPr txBox="1"/>
           <p:nvPr/>
         </p:nvSpPr>
         <p:spPr>
           <a:xfrm>
-            <a:off x="640080" y="4480560"/>
-            <a:ext cx="10881360" cy="1280160"/>
+            <a:off x="6583680" y="3931920"/>
+            <a:ext cx="4754880" cy="914400"/>
           </a:xfrm>
           <a:prstGeom prst="rect">
             <a:avLst/>
@@ -5354,58 +5469,169 @@
           <a:p>
             <a:pPr algn="l">
               <a:lnSpc>
-                <a:spcPct val="150000"/>
-              </a:lnSpc>
-            </a:pPr>
-            <a:r>
-              <a:rPr sz="1600" b="1">
-                <a:solidFill>
-                  <a:srgbClr val="C1A231"/>
+                <a:spcPct val="110000"/>
+              </a:lnSpc>
+            </a:pPr>
+            <a:r>
+              <a:rPr sz="1500" b="1">
+                <a:solidFill>
+                  <a:srgbClr val="840028"/>
+                </a:solidFill>
+                <a:latin typeface="Georgia"/>
+              </a:rPr>
+              <a:t>You leave with: </a:t>
+            </a:r>
+            <a:r>
+              <a:rPr sz="1500" b="0">
+                <a:solidFill>
+                  <a:srgbClr val="000000"/>
+                </a:solidFill>
+                <a:latin typeface="Georgia"/>
+              </a:rPr>
+              <a:t>The pain point, with numbers, for your business model and your Dec 4 pitch.</a:t>
+            </a:r>
+          </a:p>
+        </p:txBody>
+      </p:sp>
+      <p:sp>
+        <p:nvSpPr>
+          <p:cNvPr id="15" name="Rectangle 14"/>
+          <p:cNvSpPr/>
+          <p:nvPr/>
+        </p:nvSpPr>
+        <p:spPr>
+          <a:xfrm>
+            <a:off x="640080" y="5166360"/>
+            <a:ext cx="10908792" cy="914400"/>
+          </a:xfrm>
+          <a:prstGeom prst="rect">
+            <a:avLst/>
+          </a:prstGeom>
+          <a:solidFill>
+            <a:srgbClr val="FFFFFF"/>
+          </a:solidFill>
+          <a:ln>
+            <a:noFill/>
+          </a:ln>
+          <a:effectLst/>
+        </p:spPr>
+        <p:style>
+          <a:lnRef idx="1">
+            <a:schemeClr val="accent1"/>
+          </a:lnRef>
+          <a:fillRef idx="3">
+            <a:schemeClr val="accent1"/>
+          </a:fillRef>
+          <a:effectRef idx="2">
+            <a:schemeClr val="accent1"/>
+          </a:effectRef>
+          <a:fontRef idx="minor">
+            <a:schemeClr val="lt1"/>
+          </a:fontRef>
+        </p:style>
+        <p:txBody>
+          <a:bodyPr rtlCol="0" anchor="ctr"/>
+          <a:lstStyle/>
+          <a:p>
+            <a:pPr algn="ctr"/>
+          </a:p>
+        </p:txBody>
+      </p:sp>
+      <p:sp>
+        <p:nvSpPr>
+          <p:cNvPr id="16" name="Rectangle 15"/>
+          <p:cNvSpPr/>
+          <p:nvPr/>
+        </p:nvSpPr>
+        <p:spPr>
+          <a:xfrm>
+            <a:off x="640080" y="5166360"/>
+            <a:ext cx="109728" cy="914400"/>
+          </a:xfrm>
+          <a:prstGeom prst="rect">
+            <a:avLst/>
+          </a:prstGeom>
+          <a:solidFill>
+            <a:srgbClr val="C1A231"/>
+          </a:solidFill>
+          <a:ln>
+            <a:noFill/>
+          </a:ln>
+          <a:effectLst/>
+        </p:spPr>
+        <p:style>
+          <a:lnRef idx="1">
+            <a:schemeClr val="accent1"/>
+          </a:lnRef>
+          <a:fillRef idx="3">
+            <a:schemeClr val="accent1"/>
+          </a:fillRef>
+          <a:effectRef idx="2">
+            <a:schemeClr val="accent1"/>
+          </a:effectRef>
+          <a:fontRef idx="minor">
+            <a:schemeClr val="lt1"/>
+          </a:fontRef>
+        </p:style>
+        <p:txBody>
+          <a:bodyPr rtlCol="0" anchor="ctr"/>
+          <a:lstStyle/>
+          <a:p>
+            <a:pPr algn="ctr"/>
+          </a:p>
+        </p:txBody>
+      </p:sp>
+      <p:sp>
+        <p:nvSpPr>
+          <p:cNvPr id="17" name="TextBox 16"/>
+          <p:cNvSpPr txBox="1"/>
+          <p:nvPr/>
+        </p:nvSpPr>
+        <p:spPr>
+          <a:xfrm>
+            <a:off x="1005840" y="5166360"/>
+            <a:ext cx="10332720" cy="914400"/>
+          </a:xfrm>
+          <a:prstGeom prst="rect">
+            <a:avLst/>
+          </a:prstGeom>
+          <a:noFill/>
+        </p:spPr>
+        <p:txBody>
+          <a:bodyPr wrap="square" anchor="ctr" lIns="0" rIns="0" tIns="0" bIns="0">
+            <a:spAutoFit/>
+          </a:bodyPr>
+          <a:lstStyle/>
+          <a:p>
+            <a:pPr algn="l">
+              <a:lnSpc>
+                <a:spcPct val="110000"/>
+              </a:lnSpc>
+            </a:pPr>
+            <a:r>
+              <a:rPr sz="1500" b="1">
+                <a:solidFill>
+                  <a:srgbClr val="840028"/>
                 </a:solidFill>
                 <a:latin typeface="Arial"/>
               </a:rPr>
-              <a:t>DOCUMENTATION   </a:t>
-            </a:r>
-            <a:r>
-              <a:rPr sz="2200" b="0">
-                <a:solidFill>
-                  <a:srgbClr val="FFFFFF"/>
+              <a:t>WHY IT MATTERS  </a:t>
+            </a:r>
+            <a:r>
+              <a:rPr sz="1600" b="0">
+                <a:solidFill>
+                  <a:srgbClr val="000000"/>
                 </a:solidFill>
                 <a:latin typeface="Georgia"/>
               </a:rPr>
-              <a:t>docs.tacc.utexas.edu</a:t>
-            </a:r>
-          </a:p>
-          <a:p>
-            <a:pPr algn="l">
-              <a:lnSpc>
-                <a:spcPct val="150000"/>
-              </a:lnSpc>
-            </a:pPr>
-            <a:r>
-              <a:rPr sz="1600" b="1">
-                <a:solidFill>
-                  <a:srgbClr val="C1A231"/>
-                </a:solidFill>
-                <a:latin typeface="Arial"/>
-              </a:rPr>
-              <a:t>HELP   </a:t>
-            </a:r>
-            <a:r>
-              <a:rPr sz="2200" b="0">
-                <a:solidFill>
-                  <a:srgbClr val="FFFFFF"/>
-                </a:solidFill>
-                <a:latin typeface="Georgia"/>
-              </a:rPr>
-              <a:t>ashley.scruse@morehouse.edu</a:t>
-            </a:r>
-          </a:p>
-        </p:txBody>
-      </p:sp>
-      <p:sp>
-        <p:nvSpPr>
-          <p:cNvPr id="13" name="TextBox 12"/>
+              <a:t>Swap "we think people struggle with payments" for "this many people said so." The pain points you find this fall become the requirements for your open payments prototype in the spring.</a:t>
+            </a:r>
+          </a:p>
+        </p:txBody>
+      </p:sp>
+      <p:sp>
+        <p:nvSpPr>
+          <p:cNvPr id="18" name="TextBox 17"/>
           <p:cNvSpPr txBox="1"/>
           <p:nvPr/>
         </p:nvSpPr>
@@ -5434,6 +5660,1002 @@
               <a:rPr sz="1000" b="1">
                 <a:solidFill>
                   <a:srgbClr val="D8B8C2"/>
+                </a:solidFill>
+                <a:latin typeface="Arial"/>
+              </a:rPr>
+              <a:t>MOREHOUSE SUPERCOMPUTING FACILITY  ·  HPC OFFICE HOURS</a:t>
+            </a:r>
+          </a:p>
+        </p:txBody>
+      </p:sp>
+    </p:spTree>
+  </p:cSld>
+  <p:clrMapOvr>
+    <a:masterClrMapping/>
+  </p:clrMapOvr>
+</p:sld>
+</file>
+
+<file path=ppt/slides/slide13.xml><?xml version="1.0" encoding="utf-8"?>
+<p:sld xmlns:a="http://schemas.openxmlformats.org/drawingml/2006/main" xmlns:p="http://schemas.openxmlformats.org/presentationml/2006/main" xmlns:r="http://schemas.openxmlformats.org/officeDocument/2006/relationships">
+  <p:cSld>
+    <p:bg>
+      <p:bgPr>
+        <a:solidFill>
+          <a:srgbClr val="FFFFFF"/>
+        </a:solidFill>
+        <a:effectLst/>
+      </p:bgPr>
+    </p:bg>
+    <p:spTree>
+      <p:nvGrpSpPr>
+        <p:cNvPr id="1" name=""/>
+        <p:cNvGrpSpPr/>
+        <p:nvPr/>
+      </p:nvGrpSpPr>
+      <p:grpSpPr/>
+      <p:sp>
+        <p:nvSpPr>
+          <p:cNvPr id="2" name="TextBox 1"/>
+          <p:cNvSpPr txBox="1"/>
+          <p:nvPr/>
+        </p:nvSpPr>
+        <p:spPr>
+          <a:xfrm>
+            <a:off x="640080" y="502920"/>
+            <a:ext cx="10881360" cy="822960"/>
+          </a:xfrm>
+          <a:prstGeom prst="rect">
+            <a:avLst/>
+          </a:prstGeom>
+          <a:noFill/>
+        </p:spPr>
+        <p:txBody>
+          <a:bodyPr wrap="square" anchor="t" lIns="0" rIns="0" tIns="0" bIns="0">
+            <a:spAutoFit/>
+          </a:bodyPr>
+          <a:lstStyle/>
+          <a:p>
+            <a:pPr algn="l">
+              <a:lnSpc>
+                <a:spcPct val="110000"/>
+              </a:lnSpc>
+            </a:pPr>
+            <a:r>
+              <a:rPr sz="3400" b="1">
+                <a:solidFill>
+                  <a:srgbClr val="840028"/>
+                </a:solidFill>
+                <a:latin typeface="Arial"/>
+              </a:rPr>
+              <a:t>LET'S CONNECT</a:t>
+            </a:r>
+          </a:p>
+        </p:txBody>
+      </p:sp>
+      <p:sp>
+        <p:nvSpPr>
+          <p:cNvPr id="3" name="Rectangle 2"/>
+          <p:cNvSpPr/>
+          <p:nvPr/>
+        </p:nvSpPr>
+        <p:spPr>
+          <a:xfrm>
+            <a:off x="640080" y="1344168"/>
+            <a:ext cx="1005840" cy="73152"/>
+          </a:xfrm>
+          <a:prstGeom prst="rect">
+            <a:avLst/>
+          </a:prstGeom>
+          <a:solidFill>
+            <a:srgbClr val="C1A231"/>
+          </a:solidFill>
+          <a:ln>
+            <a:noFill/>
+          </a:ln>
+          <a:effectLst/>
+        </p:spPr>
+        <p:style>
+          <a:lnRef idx="1">
+            <a:schemeClr val="accent1"/>
+          </a:lnRef>
+          <a:fillRef idx="3">
+            <a:schemeClr val="accent1"/>
+          </a:fillRef>
+          <a:effectRef idx="2">
+            <a:schemeClr val="accent1"/>
+          </a:effectRef>
+          <a:fontRef idx="minor">
+            <a:schemeClr val="lt1"/>
+          </a:fontRef>
+        </p:style>
+        <p:txBody>
+          <a:bodyPr rtlCol="0" anchor="ctr"/>
+          <a:lstStyle/>
+          <a:p>
+            <a:pPr algn="ctr"/>
+          </a:p>
+        </p:txBody>
+      </p:sp>
+      <p:sp>
+        <p:nvSpPr>
+          <p:cNvPr id="4" name="Rectangle 3"/>
+          <p:cNvSpPr/>
+          <p:nvPr/>
+        </p:nvSpPr>
+        <p:spPr>
+          <a:xfrm>
+            <a:off x="640080" y="1737360"/>
+            <a:ext cx="5317236" cy="4023360"/>
+          </a:xfrm>
+          <a:prstGeom prst="rect">
+            <a:avLst/>
+          </a:prstGeom>
+          <a:solidFill>
+            <a:srgbClr val="840028"/>
+          </a:solidFill>
+          <a:ln>
+            <a:noFill/>
+          </a:ln>
+          <a:effectLst/>
+        </p:spPr>
+        <p:style>
+          <a:lnRef idx="1">
+            <a:schemeClr val="accent1"/>
+          </a:lnRef>
+          <a:fillRef idx="3">
+            <a:schemeClr val="accent1"/>
+          </a:fillRef>
+          <a:effectRef idx="2">
+            <a:schemeClr val="accent1"/>
+          </a:effectRef>
+          <a:fontRef idx="minor">
+            <a:schemeClr val="lt1"/>
+          </a:fontRef>
+        </p:style>
+        <p:txBody>
+          <a:bodyPr rtlCol="0" anchor="ctr"/>
+          <a:lstStyle/>
+          <a:p>
+            <a:pPr algn="ctr"/>
+          </a:p>
+        </p:txBody>
+      </p:sp>
+      <p:sp>
+        <p:nvSpPr>
+          <p:cNvPr id="5" name="Rectangle 4"/>
+          <p:cNvSpPr/>
+          <p:nvPr/>
+        </p:nvSpPr>
+        <p:spPr>
+          <a:xfrm>
+            <a:off x="640080" y="1737360"/>
+            <a:ext cx="5317236" cy="73152"/>
+          </a:xfrm>
+          <a:prstGeom prst="rect">
+            <a:avLst/>
+          </a:prstGeom>
+          <a:solidFill>
+            <a:srgbClr val="C1A231"/>
+          </a:solidFill>
+          <a:ln>
+            <a:noFill/>
+          </a:ln>
+          <a:effectLst/>
+        </p:spPr>
+        <p:style>
+          <a:lnRef idx="1">
+            <a:schemeClr val="accent1"/>
+          </a:lnRef>
+          <a:fillRef idx="3">
+            <a:schemeClr val="accent1"/>
+          </a:fillRef>
+          <a:effectRef idx="2">
+            <a:schemeClr val="accent1"/>
+          </a:effectRef>
+          <a:fontRef idx="minor">
+            <a:schemeClr val="lt1"/>
+          </a:fontRef>
+        </p:style>
+        <p:txBody>
+          <a:bodyPr rtlCol="0" anchor="ctr"/>
+          <a:lstStyle/>
+          <a:p>
+            <a:pPr algn="ctr"/>
+          </a:p>
+        </p:txBody>
+      </p:sp>
+      <p:sp>
+        <p:nvSpPr>
+          <p:cNvPr id="6" name="TextBox 5"/>
+          <p:cNvSpPr txBox="1"/>
+          <p:nvPr/>
+        </p:nvSpPr>
+        <p:spPr>
+          <a:xfrm>
+            <a:off x="1005840" y="2011680"/>
+            <a:ext cx="4585716" cy="457200"/>
+          </a:xfrm>
+          <a:prstGeom prst="rect">
+            <a:avLst/>
+          </a:prstGeom>
+          <a:noFill/>
+        </p:spPr>
+        <p:txBody>
+          <a:bodyPr wrap="square" anchor="t" lIns="0" rIns="0" tIns="0" bIns="0">
+            <a:spAutoFit/>
+          </a:bodyPr>
+          <a:lstStyle/>
+          <a:p>
+            <a:pPr algn="l">
+              <a:lnSpc>
+                <a:spcPct val="110000"/>
+              </a:lnSpc>
+            </a:pPr>
+            <a:r>
+              <a:rPr sz="2000" b="1">
+                <a:solidFill>
+                  <a:srgbClr val="C1A231"/>
+                </a:solidFill>
+                <a:latin typeface="Arial"/>
+              </a:rPr>
+              <a:t>DR. ASHLEY SCRUSE</a:t>
+            </a:r>
+          </a:p>
+        </p:txBody>
+      </p:sp>
+      <p:sp>
+        <p:nvSpPr>
+          <p:cNvPr id="7" name="TextBox 6"/>
+          <p:cNvSpPr txBox="1"/>
+          <p:nvPr/>
+        </p:nvSpPr>
+        <p:spPr>
+          <a:xfrm>
+            <a:off x="1005840" y="2697480"/>
+            <a:ext cx="4585716" cy="274320"/>
+          </a:xfrm>
+          <a:prstGeom prst="rect">
+            <a:avLst/>
+          </a:prstGeom>
+          <a:noFill/>
+        </p:spPr>
+        <p:txBody>
+          <a:bodyPr wrap="square" anchor="t" lIns="0" rIns="0" tIns="0" bIns="0">
+            <a:spAutoFit/>
+          </a:bodyPr>
+          <a:lstStyle/>
+          <a:p>
+            <a:pPr algn="l">
+              <a:lnSpc>
+                <a:spcPct val="110000"/>
+              </a:lnSpc>
+            </a:pPr>
+            <a:r>
+              <a:rPr sz="1200" b="1">
+                <a:solidFill>
+                  <a:srgbClr val="D8B8C2"/>
+                </a:solidFill>
+                <a:latin typeface="Arial"/>
+              </a:rPr>
+              <a:t>LINKEDIN</a:t>
+            </a:r>
+          </a:p>
+        </p:txBody>
+      </p:sp>
+      <p:sp>
+        <p:nvSpPr>
+          <p:cNvPr id="8" name="TextBox 7"/>
+          <p:cNvSpPr txBox="1"/>
+          <p:nvPr/>
+        </p:nvSpPr>
+        <p:spPr>
+          <a:xfrm>
+            <a:off x="1005840" y="2971800"/>
+            <a:ext cx="4585716" cy="365760"/>
+          </a:xfrm>
+          <a:prstGeom prst="rect">
+            <a:avLst/>
+          </a:prstGeom>
+          <a:noFill/>
+        </p:spPr>
+        <p:txBody>
+          <a:bodyPr wrap="square" anchor="t" lIns="0" rIns="0" tIns="0" bIns="0">
+            <a:spAutoFit/>
+          </a:bodyPr>
+          <a:lstStyle/>
+          <a:p>
+            <a:pPr algn="l">
+              <a:lnSpc>
+                <a:spcPct val="110000"/>
+              </a:lnSpc>
+            </a:pPr>
+            <a:r>
+              <a:rPr sz="1800" b="0">
+                <a:solidFill>
+                  <a:srgbClr val="FFFFFF"/>
+                </a:solidFill>
+                <a:latin typeface="Georgia"/>
+              </a:rPr>
+              <a:t>linkedin.com/in/ashleyscruse</a:t>
+            </a:r>
+          </a:p>
+        </p:txBody>
+      </p:sp>
+      <p:sp>
+        <p:nvSpPr>
+          <p:cNvPr id="9" name="TextBox 8"/>
+          <p:cNvSpPr txBox="1"/>
+          <p:nvPr/>
+        </p:nvSpPr>
+        <p:spPr>
+          <a:xfrm>
+            <a:off x="1005840" y="3429000"/>
+            <a:ext cx="4585716" cy="274320"/>
+          </a:xfrm>
+          <a:prstGeom prst="rect">
+            <a:avLst/>
+          </a:prstGeom>
+          <a:noFill/>
+        </p:spPr>
+        <p:txBody>
+          <a:bodyPr wrap="square" anchor="t" lIns="0" rIns="0" tIns="0" bIns="0">
+            <a:spAutoFit/>
+          </a:bodyPr>
+          <a:lstStyle/>
+          <a:p>
+            <a:pPr algn="l">
+              <a:lnSpc>
+                <a:spcPct val="110000"/>
+              </a:lnSpc>
+            </a:pPr>
+            <a:r>
+              <a:rPr sz="1200" b="1">
+                <a:solidFill>
+                  <a:srgbClr val="D8B8C2"/>
+                </a:solidFill>
+                <a:latin typeface="Arial"/>
+              </a:rPr>
+              <a:t>EMAIL</a:t>
+            </a:r>
+          </a:p>
+        </p:txBody>
+      </p:sp>
+      <p:sp>
+        <p:nvSpPr>
+          <p:cNvPr id="10" name="TextBox 9"/>
+          <p:cNvSpPr txBox="1"/>
+          <p:nvPr/>
+        </p:nvSpPr>
+        <p:spPr>
+          <a:xfrm>
+            <a:off x="1005840" y="3703320"/>
+            <a:ext cx="4585716" cy="365760"/>
+          </a:xfrm>
+          <a:prstGeom prst="rect">
+            <a:avLst/>
+          </a:prstGeom>
+          <a:noFill/>
+        </p:spPr>
+        <p:txBody>
+          <a:bodyPr wrap="square" anchor="t" lIns="0" rIns="0" tIns="0" bIns="0">
+            <a:spAutoFit/>
+          </a:bodyPr>
+          <a:lstStyle/>
+          <a:p>
+            <a:pPr algn="l">
+              <a:lnSpc>
+                <a:spcPct val="110000"/>
+              </a:lnSpc>
+            </a:pPr>
+            <a:r>
+              <a:rPr sz="1800" b="0">
+                <a:solidFill>
+                  <a:srgbClr val="FFFFFF"/>
+                </a:solidFill>
+                <a:latin typeface="Georgia"/>
+              </a:rPr>
+              <a:t>ashley.scruse@morehouse.edu</a:t>
+            </a:r>
+          </a:p>
+        </p:txBody>
+      </p:sp>
+      <p:sp>
+        <p:nvSpPr>
+          <p:cNvPr id="11" name="TextBox 10"/>
+          <p:cNvSpPr txBox="1"/>
+          <p:nvPr/>
+        </p:nvSpPr>
+        <p:spPr>
+          <a:xfrm>
+            <a:off x="1005840" y="4160520"/>
+            <a:ext cx="4585716" cy="274320"/>
+          </a:xfrm>
+          <a:prstGeom prst="rect">
+            <a:avLst/>
+          </a:prstGeom>
+          <a:noFill/>
+        </p:spPr>
+        <p:txBody>
+          <a:bodyPr wrap="square" anchor="t" lIns="0" rIns="0" tIns="0" bIns="0">
+            <a:spAutoFit/>
+          </a:bodyPr>
+          <a:lstStyle/>
+          <a:p>
+            <a:pPr algn="l">
+              <a:lnSpc>
+                <a:spcPct val="110000"/>
+              </a:lnSpc>
+            </a:pPr>
+            <a:r>
+              <a:rPr sz="1200" b="1">
+                <a:solidFill>
+                  <a:srgbClr val="D8B8C2"/>
+                </a:solidFill>
+                <a:latin typeface="Arial"/>
+              </a:rPr>
+              <a:t>GITHUB</a:t>
+            </a:r>
+          </a:p>
+        </p:txBody>
+      </p:sp>
+      <p:sp>
+        <p:nvSpPr>
+          <p:cNvPr id="12" name="TextBox 11"/>
+          <p:cNvSpPr txBox="1"/>
+          <p:nvPr/>
+        </p:nvSpPr>
+        <p:spPr>
+          <a:xfrm>
+            <a:off x="1005840" y="4434840"/>
+            <a:ext cx="4585716" cy="365760"/>
+          </a:xfrm>
+          <a:prstGeom prst="rect">
+            <a:avLst/>
+          </a:prstGeom>
+          <a:noFill/>
+        </p:spPr>
+        <p:txBody>
+          <a:bodyPr wrap="square" anchor="t" lIns="0" rIns="0" tIns="0" bIns="0">
+            <a:spAutoFit/>
+          </a:bodyPr>
+          <a:lstStyle/>
+          <a:p>
+            <a:pPr algn="l">
+              <a:lnSpc>
+                <a:spcPct val="110000"/>
+              </a:lnSpc>
+            </a:pPr>
+            <a:r>
+              <a:rPr sz="1800" b="0">
+                <a:solidFill>
+                  <a:srgbClr val="FFFFFF"/>
+                </a:solidFill>
+                <a:latin typeface="Georgia"/>
+              </a:rPr>
+              <a:t>github.com/ashleyscruse</a:t>
+            </a:r>
+          </a:p>
+        </p:txBody>
+      </p:sp>
+      <p:sp>
+        <p:nvSpPr>
+          <p:cNvPr id="13" name="Rectangle 12"/>
+          <p:cNvSpPr/>
+          <p:nvPr/>
+        </p:nvSpPr>
+        <p:spPr>
+          <a:xfrm>
+            <a:off x="6231636" y="1737360"/>
+            <a:ext cx="5317236" cy="4023360"/>
+          </a:xfrm>
+          <a:prstGeom prst="rect">
+            <a:avLst/>
+          </a:prstGeom>
+          <a:solidFill>
+            <a:srgbClr val="F4F1F2"/>
+          </a:solidFill>
+          <a:ln>
+            <a:noFill/>
+          </a:ln>
+          <a:effectLst/>
+        </p:spPr>
+        <p:style>
+          <a:lnRef idx="1">
+            <a:schemeClr val="accent1"/>
+          </a:lnRef>
+          <a:fillRef idx="3">
+            <a:schemeClr val="accent1"/>
+          </a:fillRef>
+          <a:effectRef idx="2">
+            <a:schemeClr val="accent1"/>
+          </a:effectRef>
+          <a:fontRef idx="minor">
+            <a:schemeClr val="lt1"/>
+          </a:fontRef>
+        </p:style>
+        <p:txBody>
+          <a:bodyPr rtlCol="0" anchor="ctr"/>
+          <a:lstStyle/>
+          <a:p>
+            <a:pPr algn="ctr"/>
+          </a:p>
+        </p:txBody>
+      </p:sp>
+      <p:sp>
+        <p:nvSpPr>
+          <p:cNvPr id="14" name="Rectangle 13"/>
+          <p:cNvSpPr/>
+          <p:nvPr/>
+        </p:nvSpPr>
+        <p:spPr>
+          <a:xfrm>
+            <a:off x="6231636" y="1737360"/>
+            <a:ext cx="5317236" cy="73152"/>
+          </a:xfrm>
+          <a:prstGeom prst="rect">
+            <a:avLst/>
+          </a:prstGeom>
+          <a:solidFill>
+            <a:srgbClr val="C1A231"/>
+          </a:solidFill>
+          <a:ln>
+            <a:noFill/>
+          </a:ln>
+          <a:effectLst/>
+        </p:spPr>
+        <p:style>
+          <a:lnRef idx="1">
+            <a:schemeClr val="accent1"/>
+          </a:lnRef>
+          <a:fillRef idx="3">
+            <a:schemeClr val="accent1"/>
+          </a:fillRef>
+          <a:effectRef idx="2">
+            <a:schemeClr val="accent1"/>
+          </a:effectRef>
+          <a:fontRef idx="minor">
+            <a:schemeClr val="lt1"/>
+          </a:fontRef>
+        </p:style>
+        <p:txBody>
+          <a:bodyPr rtlCol="0" anchor="ctr"/>
+          <a:lstStyle/>
+          <a:p>
+            <a:pPr algn="ctr"/>
+          </a:p>
+        </p:txBody>
+      </p:sp>
+      <p:sp>
+        <p:nvSpPr>
+          <p:cNvPr id="15" name="TextBox 14"/>
+          <p:cNvSpPr txBox="1"/>
+          <p:nvPr/>
+        </p:nvSpPr>
+        <p:spPr>
+          <a:xfrm>
+            <a:off x="6597396" y="2011680"/>
+            <a:ext cx="4585716" cy="457200"/>
+          </a:xfrm>
+          <a:prstGeom prst="rect">
+            <a:avLst/>
+          </a:prstGeom>
+          <a:noFill/>
+        </p:spPr>
+        <p:txBody>
+          <a:bodyPr wrap="square" anchor="t" lIns="0" rIns="0" tIns="0" bIns="0">
+            <a:spAutoFit/>
+          </a:bodyPr>
+          <a:lstStyle/>
+          <a:p>
+            <a:pPr algn="l">
+              <a:lnSpc>
+                <a:spcPct val="110000"/>
+              </a:lnSpc>
+            </a:pPr>
+            <a:r>
+              <a:rPr sz="2000" b="1">
+                <a:solidFill>
+                  <a:srgbClr val="840028"/>
+                </a:solidFill>
+                <a:latin typeface="Arial"/>
+              </a:rPr>
+              <a:t>STAY LOCKED IN</a:t>
+            </a:r>
+          </a:p>
+        </p:txBody>
+      </p:sp>
+      <p:sp>
+        <p:nvSpPr>
+          <p:cNvPr id="16" name="TextBox 15"/>
+          <p:cNvSpPr txBox="1"/>
+          <p:nvPr/>
+        </p:nvSpPr>
+        <p:spPr>
+          <a:xfrm>
+            <a:off x="6597396" y="2697480"/>
+            <a:ext cx="4585716" cy="274320"/>
+          </a:xfrm>
+          <a:prstGeom prst="rect">
+            <a:avLst/>
+          </a:prstGeom>
+          <a:noFill/>
+        </p:spPr>
+        <p:txBody>
+          <a:bodyPr wrap="square" anchor="t" lIns="0" rIns="0" tIns="0" bIns="0">
+            <a:spAutoFit/>
+          </a:bodyPr>
+          <a:lstStyle/>
+          <a:p>
+            <a:pPr algn="l">
+              <a:lnSpc>
+                <a:spcPct val="110000"/>
+              </a:lnSpc>
+            </a:pPr>
+            <a:r>
+              <a:rPr sz="1200" b="1">
+                <a:solidFill>
+                  <a:srgbClr val="4A4A4A"/>
+                </a:solidFill>
+                <a:latin typeface="Arial"/>
+              </a:rPr>
+              <a:t>MSF LINKEDIN</a:t>
+            </a:r>
+          </a:p>
+        </p:txBody>
+      </p:sp>
+      <p:sp>
+        <p:nvSpPr>
+          <p:cNvPr id="17" name="TextBox 16"/>
+          <p:cNvSpPr txBox="1"/>
+          <p:nvPr/>
+        </p:nvSpPr>
+        <p:spPr>
+          <a:xfrm>
+            <a:off x="6597396" y="2971800"/>
+            <a:ext cx="4585716" cy="365760"/>
+          </a:xfrm>
+          <a:prstGeom prst="rect">
+            <a:avLst/>
+          </a:prstGeom>
+          <a:noFill/>
+        </p:spPr>
+        <p:txBody>
+          <a:bodyPr wrap="square" anchor="t" lIns="0" rIns="0" tIns="0" bIns="0">
+            <a:spAutoFit/>
+          </a:bodyPr>
+          <a:lstStyle/>
+          <a:p>
+            <a:pPr algn="l">
+              <a:lnSpc>
+                <a:spcPct val="110000"/>
+              </a:lnSpc>
+            </a:pPr>
+            <a:r>
+              <a:rPr sz="1800" b="0">
+                <a:solidFill>
+                  <a:srgbClr val="000000"/>
+                </a:solidFill>
+                <a:latin typeface="Georgia"/>
+              </a:rPr>
+              <a:t>[MSF LinkedIn URL]</a:t>
+            </a:r>
+          </a:p>
+        </p:txBody>
+      </p:sp>
+      <p:sp>
+        <p:nvSpPr>
+          <p:cNvPr id="18" name="TextBox 17"/>
+          <p:cNvSpPr txBox="1"/>
+          <p:nvPr/>
+        </p:nvSpPr>
+        <p:spPr>
+          <a:xfrm>
+            <a:off x="6597396" y="3429000"/>
+            <a:ext cx="4585716" cy="274320"/>
+          </a:xfrm>
+          <a:prstGeom prst="rect">
+            <a:avLst/>
+          </a:prstGeom>
+          <a:noFill/>
+        </p:spPr>
+        <p:txBody>
+          <a:bodyPr wrap="square" anchor="t" lIns="0" rIns="0" tIns="0" bIns="0">
+            <a:spAutoFit/>
+          </a:bodyPr>
+          <a:lstStyle/>
+          <a:p>
+            <a:pPr algn="l">
+              <a:lnSpc>
+                <a:spcPct val="110000"/>
+              </a:lnSpc>
+            </a:pPr>
+            <a:r>
+              <a:rPr sz="1200" b="1">
+                <a:solidFill>
+                  <a:srgbClr val="4A4A4A"/>
+                </a:solidFill>
+                <a:latin typeface="Arial"/>
+              </a:rPr>
+              <a:t>CBPC LINKEDIN</a:t>
+            </a:r>
+          </a:p>
+        </p:txBody>
+      </p:sp>
+      <p:sp>
+        <p:nvSpPr>
+          <p:cNvPr id="19" name="TextBox 18"/>
+          <p:cNvSpPr txBox="1"/>
+          <p:nvPr/>
+        </p:nvSpPr>
+        <p:spPr>
+          <a:xfrm>
+            <a:off x="6597396" y="3703320"/>
+            <a:ext cx="4585716" cy="365760"/>
+          </a:xfrm>
+          <a:prstGeom prst="rect">
+            <a:avLst/>
+          </a:prstGeom>
+          <a:noFill/>
+        </p:spPr>
+        <p:txBody>
+          <a:bodyPr wrap="square" anchor="t" lIns="0" rIns="0" tIns="0" bIns="0">
+            <a:spAutoFit/>
+          </a:bodyPr>
+          <a:lstStyle/>
+          <a:p>
+            <a:pPr algn="l">
+              <a:lnSpc>
+                <a:spcPct val="110000"/>
+              </a:lnSpc>
+            </a:pPr>
+            <a:r>
+              <a:rPr sz="1800" b="0">
+                <a:solidFill>
+                  <a:srgbClr val="000000"/>
+                </a:solidFill>
+                <a:latin typeface="Georgia"/>
+              </a:rPr>
+              <a:t>linkedin.com/company/morehousecbpc</a:t>
+            </a:r>
+          </a:p>
+        </p:txBody>
+      </p:sp>
+      <p:sp>
+        <p:nvSpPr>
+          <p:cNvPr id="20" name="TextBox 19"/>
+          <p:cNvSpPr txBox="1"/>
+          <p:nvPr/>
+        </p:nvSpPr>
+        <p:spPr>
+          <a:xfrm>
+            <a:off x="6597396" y="4160520"/>
+            <a:ext cx="4585716" cy="274320"/>
+          </a:xfrm>
+          <a:prstGeom prst="rect">
+            <a:avLst/>
+          </a:prstGeom>
+          <a:noFill/>
+        </p:spPr>
+        <p:txBody>
+          <a:bodyPr wrap="square" anchor="t" lIns="0" rIns="0" tIns="0" bIns="0">
+            <a:spAutoFit/>
+          </a:bodyPr>
+          <a:lstStyle/>
+          <a:p>
+            <a:pPr algn="l">
+              <a:lnSpc>
+                <a:spcPct val="110000"/>
+              </a:lnSpc>
+            </a:pPr>
+            <a:r>
+              <a:rPr sz="1200" b="1">
+                <a:solidFill>
+                  <a:srgbClr val="4A4A4A"/>
+                </a:solidFill>
+                <a:latin typeface="Arial"/>
+              </a:rPr>
+              <a:t>CBPC</a:t>
+            </a:r>
+          </a:p>
+        </p:txBody>
+      </p:sp>
+      <p:sp>
+        <p:nvSpPr>
+          <p:cNvPr id="21" name="TextBox 20"/>
+          <p:cNvSpPr txBox="1"/>
+          <p:nvPr/>
+        </p:nvSpPr>
+        <p:spPr>
+          <a:xfrm>
+            <a:off x="6597396" y="4434840"/>
+            <a:ext cx="4585716" cy="365760"/>
+          </a:xfrm>
+          <a:prstGeom prst="rect">
+            <a:avLst/>
+          </a:prstGeom>
+          <a:noFill/>
+        </p:spPr>
+        <p:txBody>
+          <a:bodyPr wrap="square" anchor="t" lIns="0" rIns="0" tIns="0" bIns="0">
+            <a:spAutoFit/>
+          </a:bodyPr>
+          <a:lstStyle/>
+          <a:p>
+            <a:pPr algn="l">
+              <a:lnSpc>
+                <a:spcPct val="110000"/>
+              </a:lnSpc>
+            </a:pPr>
+            <a:r>
+              <a:rPr sz="1800" b="0">
+                <a:solidFill>
+                  <a:srgbClr val="000000"/>
+                </a:solidFill>
+                <a:latin typeface="Georgia"/>
+              </a:rPr>
+              <a:t>bpccenter.org</a:t>
+            </a:r>
+          </a:p>
+        </p:txBody>
+      </p:sp>
+      <p:sp>
+        <p:nvSpPr>
+          <p:cNvPr id="22" name="TextBox 21"/>
+          <p:cNvSpPr txBox="1"/>
+          <p:nvPr/>
+        </p:nvSpPr>
+        <p:spPr>
+          <a:xfrm>
+            <a:off x="6597396" y="4892040"/>
+            <a:ext cx="4585716" cy="274320"/>
+          </a:xfrm>
+          <a:prstGeom prst="rect">
+            <a:avLst/>
+          </a:prstGeom>
+          <a:noFill/>
+        </p:spPr>
+        <p:txBody>
+          <a:bodyPr wrap="square" anchor="t" lIns="0" rIns="0" tIns="0" bIns="0">
+            <a:spAutoFit/>
+          </a:bodyPr>
+          <a:lstStyle/>
+          <a:p>
+            <a:pPr algn="l">
+              <a:lnSpc>
+                <a:spcPct val="110000"/>
+              </a:lnSpc>
+            </a:pPr>
+            <a:r>
+              <a:rPr sz="1200" b="1">
+                <a:solidFill>
+                  <a:srgbClr val="4A4A4A"/>
+                </a:solidFill>
+                <a:latin typeface="Arial"/>
+              </a:rPr>
+              <a:t>MSF GITHUB</a:t>
+            </a:r>
+          </a:p>
+        </p:txBody>
+      </p:sp>
+      <p:sp>
+        <p:nvSpPr>
+          <p:cNvPr id="23" name="TextBox 22"/>
+          <p:cNvSpPr txBox="1"/>
+          <p:nvPr/>
+        </p:nvSpPr>
+        <p:spPr>
+          <a:xfrm>
+            <a:off x="6597396" y="5166360"/>
+            <a:ext cx="4585716" cy="365760"/>
+          </a:xfrm>
+          <a:prstGeom prst="rect">
+            <a:avLst/>
+          </a:prstGeom>
+          <a:noFill/>
+        </p:spPr>
+        <p:txBody>
+          <a:bodyPr wrap="square" anchor="t" lIns="0" rIns="0" tIns="0" bIns="0">
+            <a:spAutoFit/>
+          </a:bodyPr>
+          <a:lstStyle/>
+          <a:p>
+            <a:pPr algn="l">
+              <a:lnSpc>
+                <a:spcPct val="110000"/>
+              </a:lnSpc>
+            </a:pPr>
+            <a:r>
+              <a:rPr sz="1800" b="0">
+                <a:solidFill>
+                  <a:srgbClr val="000000"/>
+                </a:solidFill>
+                <a:latin typeface="Georgia"/>
+              </a:rPr>
+              <a:t>github.com/morehouse-supercomputing</a:t>
+            </a:r>
+          </a:p>
+        </p:txBody>
+      </p:sp>
+      <p:sp>
+        <p:nvSpPr>
+          <p:cNvPr id="24" name="TextBox 23"/>
+          <p:cNvSpPr txBox="1"/>
+          <p:nvPr/>
+        </p:nvSpPr>
+        <p:spPr>
+          <a:xfrm>
+            <a:off x="640080" y="5897880"/>
+            <a:ext cx="10881360" cy="365760"/>
+          </a:xfrm>
+          <a:prstGeom prst="rect">
+            <a:avLst/>
+          </a:prstGeom>
+          <a:noFill/>
+        </p:spPr>
+        <p:txBody>
+          <a:bodyPr wrap="square" anchor="t" lIns="0" rIns="0" tIns="0" bIns="0">
+            <a:spAutoFit/>
+          </a:bodyPr>
+          <a:lstStyle/>
+          <a:p>
+            <a:pPr algn="l">
+              <a:lnSpc>
+                <a:spcPct val="110000"/>
+              </a:lnSpc>
+            </a:pPr>
+            <a:r>
+              <a:rPr sz="1600" b="1">
+                <a:solidFill>
+                  <a:srgbClr val="840028"/>
+                </a:solidFill>
+                <a:latin typeface="Georgia"/>
+              </a:rPr>
+              <a:t>Guide from tonight: </a:t>
+            </a:r>
+            <a:r>
+              <a:rPr sz="1600" b="0">
+                <a:solidFill>
+                  <a:srgbClr val="000000"/>
+                </a:solidFill>
+                <a:latin typeface="Georgia"/>
+              </a:rPr>
+              <a:t>morehouse-supercomputing.github.io/hpc-office-hours</a:t>
+            </a:r>
+          </a:p>
+        </p:txBody>
+      </p:sp>
+      <p:sp>
+        <p:nvSpPr>
+          <p:cNvPr id="25" name="TextBox 24"/>
+          <p:cNvSpPr txBox="1"/>
+          <p:nvPr/>
+        </p:nvSpPr>
+        <p:spPr>
+          <a:xfrm>
+            <a:off x="640080" y="6400800"/>
+            <a:ext cx="7315200" cy="274320"/>
+          </a:xfrm>
+          <a:prstGeom prst="rect">
+            <a:avLst/>
+          </a:prstGeom>
+          <a:noFill/>
+        </p:spPr>
+        <p:txBody>
+          <a:bodyPr wrap="square" anchor="t" lIns="0" rIns="0" tIns="0" bIns="0">
+            <a:spAutoFit/>
+          </a:bodyPr>
+          <a:lstStyle/>
+          <a:p>
+            <a:pPr algn="l">
+              <a:lnSpc>
+                <a:spcPct val="110000"/>
+              </a:lnSpc>
+            </a:pPr>
+            <a:r>
+              <a:rPr sz="1000" b="1">
+                <a:solidFill>
+                  <a:srgbClr val="A7A8AA"/>
                 </a:solidFill>
                 <a:latin typeface="Arial"/>
               </a:rPr>

</xml_diff>

<commit_message>
Add speaker notes to deck
</commit_message>
<xml_diff>
--- a/slides/hpc-office-hours.pptx
+++ b/slides/hpc-office-hours.pptx
@@ -117,6 +117,1376 @@
     </a:lvl9pPr>
   </p:defaultTextStyle>
 </p:presentation>
+</file>
+
+<file path=ppt/notesMasters/notesMaster1.xml><?xml version="1.0" encoding="utf-8"?>
+<p:notesMaster xmlns:a="http://schemas.openxmlformats.org/drawingml/2006/main" xmlns:p="http://schemas.openxmlformats.org/presentationml/2006/main" xmlns:r="http://schemas.openxmlformats.org/officeDocument/2006/relationships">
+  <p:cSld>
+    <p:bg>
+      <p:bgRef idx="1001">
+        <a:schemeClr val="bg1"/>
+      </p:bgRef>
+    </p:bg>
+    <p:spTree>
+      <p:nvGrpSpPr>
+        <p:cNvPr id="1" name=""/>
+        <p:cNvGrpSpPr/>
+        <p:nvPr/>
+      </p:nvGrpSpPr>
+      <p:grpSpPr>
+        <a:xfrm>
+          <a:off x="0" y="0"/>
+          <a:ext cx="0" cy="0"/>
+          <a:chOff x="0" y="0"/>
+          <a:chExt cx="0" cy="0"/>
+        </a:xfrm>
+      </p:grpSpPr>
+      <p:sp>
+        <p:nvSpPr>
+          <p:cNvPr id="2" name="Header Placeholder 1"/>
+          <p:cNvSpPr>
+            <a:spLocks noGrp="1"/>
+          </p:cNvSpPr>
+          <p:nvPr>
+            <p:ph type="hdr" sz="quarter"/>
+          </p:nvPr>
+        </p:nvSpPr>
+        <p:spPr>
+          <a:xfrm>
+            <a:off x="0" y="0"/>
+            <a:ext cx="2971800" cy="457200"/>
+          </a:xfrm>
+          <a:prstGeom prst="rect">
+            <a:avLst/>
+          </a:prstGeom>
+        </p:spPr>
+        <p:txBody>
+          <a:bodyPr vert="horz" lIns="91440" tIns="45720" rIns="91440" bIns="45720" rtlCol="0"/>
+          <a:lstStyle>
+            <a:lvl1pPr algn="l">
+              <a:defRPr sz="1200"/>
+            </a:lvl1pPr>
+          </a:lstStyle>
+          <a:p>
+            <a:endParaRPr lang="en-US"/>
+          </a:p>
+        </p:txBody>
+      </p:sp>
+      <p:sp>
+        <p:nvSpPr>
+          <p:cNvPr id="3" name="Date Placeholder 2"/>
+          <p:cNvSpPr>
+            <a:spLocks noGrp="1"/>
+          </p:cNvSpPr>
+          <p:nvPr>
+            <p:ph type="dt" idx="1"/>
+          </p:nvPr>
+        </p:nvSpPr>
+        <p:spPr>
+          <a:xfrm>
+            <a:off x="3884613" y="0"/>
+            <a:ext cx="2971800" cy="457200"/>
+          </a:xfrm>
+          <a:prstGeom prst="rect">
+            <a:avLst/>
+          </a:prstGeom>
+        </p:spPr>
+        <p:txBody>
+          <a:bodyPr vert="horz" lIns="91440" tIns="45720" rIns="91440" bIns="45720" rtlCol="0"/>
+          <a:lstStyle>
+            <a:lvl1pPr algn="r">
+              <a:defRPr sz="1200"/>
+            </a:lvl1pPr>
+          </a:lstStyle>
+          <a:p>
+            <a:fld id="{0F89C1C7-3DCD-1040-A9CF-14679D8B5DDD}" type="datetimeFigureOut">
+              <a:rPr lang="en-US" smtClean="0"/>
+              <a:t>10/17/16</a:t>
+            </a:fld>
+            <a:endParaRPr lang="en-US"/>
+          </a:p>
+        </p:txBody>
+      </p:sp>
+      <p:sp>
+        <p:nvSpPr>
+          <p:cNvPr id="4" name="Slide Image Placeholder 3"/>
+          <p:cNvSpPr>
+            <a:spLocks noGrp="1" noRot="1" noChangeAspect="1"/>
+          </p:cNvSpPr>
+          <p:nvPr>
+            <p:ph type="sldImg" idx="2"/>
+          </p:nvPr>
+        </p:nvSpPr>
+        <p:spPr>
+          <a:xfrm>
+            <a:off x="1143000" y="685800"/>
+            <a:ext cx="4572000" cy="3429000"/>
+          </a:xfrm>
+          <a:prstGeom prst="rect">
+            <a:avLst/>
+          </a:prstGeom>
+          <a:noFill/>
+          <a:ln w="12700">
+            <a:solidFill>
+              <a:prstClr val="black"/>
+            </a:solidFill>
+          </a:ln>
+        </p:spPr>
+        <p:txBody>
+          <a:bodyPr vert="horz" lIns="91440" tIns="45720" rIns="91440" bIns="45720" rtlCol="0" anchor="ctr"/>
+          <a:lstStyle/>
+          <a:p>
+            <a:endParaRPr lang="en-US"/>
+          </a:p>
+        </p:txBody>
+      </p:sp>
+      <p:sp>
+        <p:nvSpPr>
+          <p:cNvPr id="5" name="Notes Placeholder 4"/>
+          <p:cNvSpPr>
+            <a:spLocks noGrp="1"/>
+          </p:cNvSpPr>
+          <p:nvPr>
+            <p:ph type="body" sz="quarter" idx="3"/>
+          </p:nvPr>
+        </p:nvSpPr>
+        <p:spPr>
+          <a:xfrm>
+            <a:off x="685800" y="4343400"/>
+            <a:ext cx="5486400" cy="4114800"/>
+          </a:xfrm>
+          <a:prstGeom prst="rect">
+            <a:avLst/>
+          </a:prstGeom>
+        </p:spPr>
+        <p:txBody>
+          <a:bodyPr vert="horz" lIns="91440" tIns="45720" rIns="91440" bIns="45720" rtlCol="0"/>
+          <a:lstStyle/>
+          <a:p>
+            <a:pPr lvl="0"/>
+            <a:r>
+              <a:rPr lang="en-US" smtClean="0"/>
+              <a:t>Click to edit Master text styles</a:t>
+            </a:r>
+          </a:p>
+          <a:p>
+            <a:pPr lvl="1"/>
+            <a:r>
+              <a:rPr lang="en-US" smtClean="0"/>
+              <a:t>Second level</a:t>
+            </a:r>
+          </a:p>
+          <a:p>
+            <a:pPr lvl="2"/>
+            <a:r>
+              <a:rPr lang="en-US" smtClean="0"/>
+              <a:t>Third level</a:t>
+            </a:r>
+          </a:p>
+          <a:p>
+            <a:pPr lvl="3"/>
+            <a:r>
+              <a:rPr lang="en-US" smtClean="0"/>
+              <a:t>Fourth level</a:t>
+            </a:r>
+          </a:p>
+          <a:p>
+            <a:pPr lvl="4"/>
+            <a:r>
+              <a:rPr lang="en-US" smtClean="0"/>
+              <a:t>Fifth level</a:t>
+            </a:r>
+            <a:endParaRPr lang="en-US"/>
+          </a:p>
+        </p:txBody>
+      </p:sp>
+      <p:sp>
+        <p:nvSpPr>
+          <p:cNvPr id="6" name="Footer Placeholder 5"/>
+          <p:cNvSpPr>
+            <a:spLocks noGrp="1"/>
+          </p:cNvSpPr>
+          <p:nvPr>
+            <p:ph type="ftr" sz="quarter" idx="4"/>
+          </p:nvPr>
+        </p:nvSpPr>
+        <p:spPr>
+          <a:xfrm>
+            <a:off x="0" y="8685213"/>
+            <a:ext cx="2971800" cy="457200"/>
+          </a:xfrm>
+          <a:prstGeom prst="rect">
+            <a:avLst/>
+          </a:prstGeom>
+        </p:spPr>
+        <p:txBody>
+          <a:bodyPr vert="horz" lIns="91440" tIns="45720" rIns="91440" bIns="45720" rtlCol="0" anchor="b"/>
+          <a:lstStyle>
+            <a:lvl1pPr algn="l">
+              <a:defRPr sz="1200"/>
+            </a:lvl1pPr>
+          </a:lstStyle>
+          <a:p>
+            <a:endParaRPr lang="en-US"/>
+          </a:p>
+        </p:txBody>
+      </p:sp>
+      <p:sp>
+        <p:nvSpPr>
+          <p:cNvPr id="7" name="Slide Number Placeholder 6"/>
+          <p:cNvSpPr>
+            <a:spLocks noGrp="1"/>
+          </p:cNvSpPr>
+          <p:nvPr>
+            <p:ph type="sldNum" sz="quarter" idx="5"/>
+          </p:nvPr>
+        </p:nvSpPr>
+        <p:spPr>
+          <a:xfrm>
+            <a:off x="3884613" y="8685213"/>
+            <a:ext cx="2971800" cy="457200"/>
+          </a:xfrm>
+          <a:prstGeom prst="rect">
+            <a:avLst/>
+          </a:prstGeom>
+        </p:spPr>
+        <p:txBody>
+          <a:bodyPr vert="horz" lIns="91440" tIns="45720" rIns="91440" bIns="45720" rtlCol="0" anchor="b"/>
+          <a:lstStyle>
+            <a:lvl1pPr algn="r">
+              <a:defRPr sz="1200"/>
+            </a:lvl1pPr>
+          </a:lstStyle>
+          <a:p>
+            <a:fld id="{BB5E49A5-4136-284D-997B-48E1D791AD67}" type="slidenum">
+              <a:rPr lang="en-US" smtClean="0"/>
+              <a:t>‹#›</a:t>
+            </a:fld>
+            <a:endParaRPr lang="en-US"/>
+          </a:p>
+        </p:txBody>
+      </p:sp>
+    </p:spTree>
+    <p:extLst>
+      <p:ext uri="{BB962C8B-B14F-4D97-AF65-F5344CB8AC3E}">
+        <p14:creationId xmlns:p14="http://schemas.microsoft.com/office/powerpoint/2010/main" val="2623252185"/>
+      </p:ext>
+    </p:extLst>
+  </p:cSld>
+  <p:clrMap bg1="lt1" tx1="dk1" bg2="lt2" tx2="dk2" accent1="accent1" accent2="accent2" accent3="accent3" accent4="accent4" accent5="accent5" accent6="accent6" hlink="hlink" folHlink="folHlink"/>
+  <p:notesStyle>
+    <a:lvl1pPr marL="0" algn="l" defTabSz="457200" rtl="0" eaLnBrk="1" latinLnBrk="0" hangingPunct="1">
+      <a:defRPr sz="1200" kern="1200">
+        <a:solidFill>
+          <a:schemeClr val="tx1"/>
+        </a:solidFill>
+        <a:latin typeface="+mn-lt"/>
+        <a:ea typeface="+mn-ea"/>
+        <a:cs typeface="+mn-cs"/>
+      </a:defRPr>
+    </a:lvl1pPr>
+    <a:lvl2pPr marL="457200" algn="l" defTabSz="457200" rtl="0" eaLnBrk="1" latinLnBrk="0" hangingPunct="1">
+      <a:defRPr sz="1200" kern="1200">
+        <a:solidFill>
+          <a:schemeClr val="tx1"/>
+        </a:solidFill>
+        <a:latin typeface="+mn-lt"/>
+        <a:ea typeface="+mn-ea"/>
+        <a:cs typeface="+mn-cs"/>
+      </a:defRPr>
+    </a:lvl2pPr>
+    <a:lvl3pPr marL="914400" algn="l" defTabSz="457200" rtl="0" eaLnBrk="1" latinLnBrk="0" hangingPunct="1">
+      <a:defRPr sz="1200" kern="1200">
+        <a:solidFill>
+          <a:schemeClr val="tx1"/>
+        </a:solidFill>
+        <a:latin typeface="+mn-lt"/>
+        <a:ea typeface="+mn-ea"/>
+        <a:cs typeface="+mn-cs"/>
+      </a:defRPr>
+    </a:lvl3pPr>
+    <a:lvl4pPr marL="1371600" algn="l" defTabSz="457200" rtl="0" eaLnBrk="1" latinLnBrk="0" hangingPunct="1">
+      <a:defRPr sz="1200" kern="1200">
+        <a:solidFill>
+          <a:schemeClr val="tx1"/>
+        </a:solidFill>
+        <a:latin typeface="+mn-lt"/>
+        <a:ea typeface="+mn-ea"/>
+        <a:cs typeface="+mn-cs"/>
+      </a:defRPr>
+    </a:lvl4pPr>
+    <a:lvl5pPr marL="1828800" algn="l" defTabSz="457200" rtl="0" eaLnBrk="1" latinLnBrk="0" hangingPunct="1">
+      <a:defRPr sz="1200" kern="1200">
+        <a:solidFill>
+          <a:schemeClr val="tx1"/>
+        </a:solidFill>
+        <a:latin typeface="+mn-lt"/>
+        <a:ea typeface="+mn-ea"/>
+        <a:cs typeface="+mn-cs"/>
+      </a:defRPr>
+    </a:lvl5pPr>
+    <a:lvl6pPr marL="2286000" algn="l" defTabSz="457200" rtl="0" eaLnBrk="1" latinLnBrk="0" hangingPunct="1">
+      <a:defRPr sz="1200" kern="1200">
+        <a:solidFill>
+          <a:schemeClr val="tx1"/>
+        </a:solidFill>
+        <a:latin typeface="+mn-lt"/>
+        <a:ea typeface="+mn-ea"/>
+        <a:cs typeface="+mn-cs"/>
+      </a:defRPr>
+    </a:lvl6pPr>
+    <a:lvl7pPr marL="2743200" algn="l" defTabSz="457200" rtl="0" eaLnBrk="1" latinLnBrk="0" hangingPunct="1">
+      <a:defRPr sz="1200" kern="1200">
+        <a:solidFill>
+          <a:schemeClr val="tx1"/>
+        </a:solidFill>
+        <a:latin typeface="+mn-lt"/>
+        <a:ea typeface="+mn-ea"/>
+        <a:cs typeface="+mn-cs"/>
+      </a:defRPr>
+    </a:lvl7pPr>
+    <a:lvl8pPr marL="3200400" algn="l" defTabSz="457200" rtl="0" eaLnBrk="1" latinLnBrk="0" hangingPunct="1">
+      <a:defRPr sz="1200" kern="1200">
+        <a:solidFill>
+          <a:schemeClr val="tx1"/>
+        </a:solidFill>
+        <a:latin typeface="+mn-lt"/>
+        <a:ea typeface="+mn-ea"/>
+        <a:cs typeface="+mn-cs"/>
+      </a:defRPr>
+    </a:lvl8pPr>
+    <a:lvl9pPr marL="3657600" algn="l" defTabSz="457200" rtl="0" eaLnBrk="1" latinLnBrk="0" hangingPunct="1">
+      <a:defRPr sz="1200" kern="1200">
+        <a:solidFill>
+          <a:schemeClr val="tx1"/>
+        </a:solidFill>
+        <a:latin typeface="+mn-lt"/>
+        <a:ea typeface="+mn-ea"/>
+        <a:cs typeface="+mn-cs"/>
+      </a:defRPr>
+    </a:lvl9pPr>
+  </p:notesStyle>
+</p:notesMaster>
+</file>
+
+<file path=ppt/notesSlides/notesSlide1.xml><?xml version="1.0" encoding="utf-8"?>
+<p:notes xmlns:a="http://schemas.openxmlformats.org/drawingml/2006/main" xmlns:p="http://schemas.openxmlformats.org/presentationml/2006/main" xmlns:r="http://schemas.openxmlformats.org/officeDocument/2006/relationships">
+  <p:cSld>
+    <p:spTree>
+      <p:nvGrpSpPr>
+        <p:cNvPr id="1" name=""/>
+        <p:cNvGrpSpPr/>
+        <p:nvPr/>
+      </p:nvGrpSpPr>
+      <p:grpSpPr>
+        <a:xfrm>
+          <a:off x="0" y="0"/>
+          <a:ext cx="0" cy="0"/>
+          <a:chOff x="0" y="0"/>
+          <a:chExt cx="0" cy="0"/>
+        </a:xfrm>
+      </p:grpSpPr>
+      <p:sp>
+        <p:nvSpPr>
+          <p:cNvPr id="2" name="Slide Image Placeholder 1"/>
+          <p:cNvSpPr>
+            <a:spLocks noGrp="1"/>
+          </p:cNvSpPr>
+          <p:nvPr>
+            <p:ph type="sldImg" idx="2"/>
+          </p:nvPr>
+        </p:nvSpPr>
+        <p:spPr/>
+      </p:sp>
+      <p:sp>
+        <p:nvSpPr>
+          <p:cNvPr id="3" name="Notes Placeholder 2"/>
+          <p:cNvSpPr>
+            <a:spLocks noGrp="1"/>
+          </p:cNvSpPr>
+          <p:nvPr>
+            <p:ph type="body" idx="3" sz="quarter"/>
+          </p:nvPr>
+        </p:nvSpPr>
+        <p:spPr/>
+        <p:txBody>
+          <a:bodyPr/>
+          <a:lstStyle/>
+          <a:p>
+            <a:r>
+              <a:t>Name, Deputy Director, MSF.</a:t>
+            </a:r>
+          </a:p>
+          <a:p>
+            <a:r>
+              <a:t>Relaxed hour. No jobs, no code.</a:t>
+            </a:r>
+          </a:p>
+        </p:txBody>
+      </p:sp>
+      <p:sp>
+        <p:nvSpPr>
+          <p:cNvPr id="4" name="Slide Number Placeholder 3"/>
+          <p:cNvSpPr>
+            <a:spLocks noGrp="1"/>
+          </p:cNvSpPr>
+          <p:nvPr>
+            <p:ph type="sldNum" idx="5" sz="quarter"/>
+          </p:nvPr>
+        </p:nvSpPr>
+        <p:spPr/>
+      </p:sp>
+    </p:spTree>
+  </p:cSld>
+  <p:clrMapOvr>
+    <a:masterClrMapping/>
+  </p:clrMapOvr>
+</p:notes>
+</file>
+
+<file path=ppt/notesSlides/notesSlide10.xml><?xml version="1.0" encoding="utf-8"?>
+<p:notes xmlns:a="http://schemas.openxmlformats.org/drawingml/2006/main" xmlns:p="http://schemas.openxmlformats.org/presentationml/2006/main" xmlns:r="http://schemas.openxmlformats.org/officeDocument/2006/relationships">
+  <p:cSld>
+    <p:spTree>
+      <p:nvGrpSpPr>
+        <p:cNvPr id="1" name=""/>
+        <p:cNvGrpSpPr/>
+        <p:nvPr/>
+      </p:nvGrpSpPr>
+      <p:grpSpPr>
+        <a:xfrm>
+          <a:off x="0" y="0"/>
+          <a:ext cx="0" cy="0"/>
+          <a:chOff x="0" y="0"/>
+          <a:chExt cx="0" cy="0"/>
+        </a:xfrm>
+      </p:grpSpPr>
+      <p:sp>
+        <p:nvSpPr>
+          <p:cNvPr id="2" name="Slide Image Placeholder 1"/>
+          <p:cNvSpPr>
+            <a:spLocks noGrp="1"/>
+          </p:cNvSpPr>
+          <p:nvPr>
+            <p:ph type="sldImg" idx="2"/>
+          </p:nvPr>
+        </p:nvSpPr>
+        <p:spPr/>
+      </p:sp>
+      <p:sp>
+        <p:nvSpPr>
+          <p:cNvPr id="3" name="Notes Placeholder 2"/>
+          <p:cNvSpPr>
+            <a:spLocks noGrp="1"/>
+          </p:cNvSpPr>
+          <p:nvPr>
+            <p:ph type="body" idx="3" sz="quarter"/>
+          </p:nvPr>
+        </p:nvSpPr>
+        <p:spPr/>
+        <p:txBody>
+          <a:bodyPr/>
+          <a:lstStyle/>
+          <a:p>
+            <a:r>
+              <a:t>Queue: wait your turn.</a:t>
+            </a:r>
+          </a:p>
+          <a:p>
+            <a:r>
+              <a:t>Interactive: next workshop.</a:t>
+            </a:r>
+          </a:p>
+          <a:p>
+            <a:r>
+              <a:t>Reservation: ticket.</a:t>
+            </a:r>
+          </a:p>
+          <a:p>
+            <a:r>
+              <a:t>Story: waited hours, script failed instantly.</a:t>
+            </a:r>
+          </a:p>
+        </p:txBody>
+      </p:sp>
+      <p:sp>
+        <p:nvSpPr>
+          <p:cNvPr id="4" name="Slide Number Placeholder 3"/>
+          <p:cNvSpPr>
+            <a:spLocks noGrp="1"/>
+          </p:cNvSpPr>
+          <p:nvPr>
+            <p:ph type="sldNum" idx="5" sz="quarter"/>
+          </p:nvPr>
+        </p:nvSpPr>
+        <p:spPr/>
+      </p:sp>
+    </p:spTree>
+  </p:cSld>
+  <p:clrMapOvr>
+    <a:masterClrMapping/>
+  </p:clrMapOvr>
+</p:notes>
+</file>
+
+<file path=ppt/notesSlides/notesSlide11.xml><?xml version="1.0" encoding="utf-8"?>
+<p:notes xmlns:a="http://schemas.openxmlformats.org/drawingml/2006/main" xmlns:p="http://schemas.openxmlformats.org/presentationml/2006/main" xmlns:r="http://schemas.openxmlformats.org/officeDocument/2006/relationships">
+  <p:cSld>
+    <p:spTree>
+      <p:nvGrpSpPr>
+        <p:cNvPr id="1" name=""/>
+        <p:cNvGrpSpPr/>
+        <p:nvPr/>
+      </p:nvGrpSpPr>
+      <p:grpSpPr>
+        <a:xfrm>
+          <a:off x="0" y="0"/>
+          <a:ext cx="0" cy="0"/>
+          <a:chOff x="0" y="0"/>
+          <a:chExt cx="0" cy="0"/>
+        </a:xfrm>
+      </p:grpSpPr>
+      <p:sp>
+        <p:nvSpPr>
+          <p:cNvPr id="2" name="Slide Image Placeholder 1"/>
+          <p:cNvSpPr>
+            <a:spLocks noGrp="1"/>
+          </p:cNvSpPr>
+          <p:nvPr>
+            <p:ph type="sldImg" idx="2"/>
+          </p:nvPr>
+        </p:nvSpPr>
+        <p:spPr/>
+      </p:sp>
+      <p:sp>
+        <p:nvSpPr>
+          <p:cNvPr id="3" name="Notes Placeholder 2"/>
+          <p:cNvSpPr>
+            <a:spLocks noGrp="1"/>
+          </p:cNvSpPr>
+          <p:nvPr>
+            <p:ph type="body" idx="3" sz="quarter"/>
+          </p:nvPr>
+        </p:nvSpPr>
+        <p:spPr/>
+        <p:txBody>
+          <a:bodyPr/>
+          <a:lstStyle/>
+          <a:p>
+            <a:r>
+              <a:t>Four rules. Read them out.</a:t>
+            </a:r>
+          </a:p>
+          <a:p>
+            <a:r>
+              <a:t>Then: switch to Tapis.</a:t>
+            </a:r>
+          </a:p>
+        </p:txBody>
+      </p:sp>
+      <p:sp>
+        <p:nvSpPr>
+          <p:cNvPr id="4" name="Slide Number Placeholder 3"/>
+          <p:cNvSpPr>
+            <a:spLocks noGrp="1"/>
+          </p:cNvSpPr>
+          <p:nvPr>
+            <p:ph type="sldNum" idx="5" sz="quarter"/>
+          </p:nvPr>
+        </p:nvSpPr>
+        <p:spPr/>
+      </p:sp>
+    </p:spTree>
+  </p:cSld>
+  <p:clrMapOvr>
+    <a:masterClrMapping/>
+  </p:clrMapOvr>
+</p:notes>
+</file>
+
+<file path=ppt/notesSlides/notesSlide12.xml><?xml version="1.0" encoding="utf-8"?>
+<p:notes xmlns:a="http://schemas.openxmlformats.org/drawingml/2006/main" xmlns:p="http://schemas.openxmlformats.org/presentationml/2006/main" xmlns:r="http://schemas.openxmlformats.org/officeDocument/2006/relationships">
+  <p:cSld>
+    <p:spTree>
+      <p:nvGrpSpPr>
+        <p:cNvPr id="1" name=""/>
+        <p:cNvGrpSpPr/>
+        <p:nvPr/>
+      </p:nvGrpSpPr>
+      <p:grpSpPr>
+        <a:xfrm>
+          <a:off x="0" y="0"/>
+          <a:ext cx="0" cy="0"/>
+          <a:chOff x="0" y="0"/>
+          <a:chExt cx="0" cy="0"/>
+        </a:xfrm>
+      </p:grpSpPr>
+      <p:sp>
+        <p:nvSpPr>
+          <p:cNvPr id="2" name="Slide Image Placeholder 1"/>
+          <p:cNvSpPr>
+            <a:spLocks noGrp="1"/>
+          </p:cNvSpPr>
+          <p:nvPr>
+            <p:ph type="sldImg" idx="2"/>
+          </p:nvPr>
+        </p:nvSpPr>
+        <p:spPr/>
+      </p:sp>
+      <p:sp>
+        <p:nvSpPr>
+          <p:cNvPr id="3" name="Notes Placeholder 2"/>
+          <p:cNvSpPr>
+            <a:spLocks noGrp="1"/>
+          </p:cNvSpPr>
+          <p:nvPr>
+            <p:ph type="body" idx="3" sz="quarter"/>
+          </p:nvPr>
+        </p:nvSpPr>
+        <p:spPr/>
+        <p:txBody>
+          <a:bodyPr/>
+          <a:lstStyle/>
+          <a:p>
+            <a:r>
+              <a:t>CFPB complaints, ~10M.</a:t>
+            </a:r>
+          </a:p>
+          <a:p>
+            <a:r>
+              <a:t>Oct 14: three numbers for the Canvas.</a:t>
+            </a:r>
+          </a:p>
+          <a:p>
+            <a:r>
+              <a:t>Nov 4: the pain point.</a:t>
+            </a:r>
+          </a:p>
+          <a:p>
+            <a:r>
+              <a:t>Fall evidence = spring prototype.</a:t>
+            </a:r>
+          </a:p>
+        </p:txBody>
+      </p:sp>
+      <p:sp>
+        <p:nvSpPr>
+          <p:cNvPr id="4" name="Slide Number Placeholder 3"/>
+          <p:cNvSpPr>
+            <a:spLocks noGrp="1"/>
+          </p:cNvSpPr>
+          <p:nvPr>
+            <p:ph type="sldNum" idx="5" sz="quarter"/>
+          </p:nvPr>
+        </p:nvSpPr>
+        <p:spPr/>
+      </p:sp>
+    </p:spTree>
+  </p:cSld>
+  <p:clrMapOvr>
+    <a:masterClrMapping/>
+  </p:clrMapOvr>
+</p:notes>
+</file>
+
+<file path=ppt/notesSlides/notesSlide13.xml><?xml version="1.0" encoding="utf-8"?>
+<p:notes xmlns:a="http://schemas.openxmlformats.org/drawingml/2006/main" xmlns:p="http://schemas.openxmlformats.org/presentationml/2006/main" xmlns:r="http://schemas.openxmlformats.org/officeDocument/2006/relationships">
+  <p:cSld>
+    <p:spTree>
+      <p:nvGrpSpPr>
+        <p:cNvPr id="1" name=""/>
+        <p:cNvGrpSpPr/>
+        <p:nvPr/>
+      </p:nvGrpSpPr>
+      <p:grpSpPr>
+        <a:xfrm>
+          <a:off x="0" y="0"/>
+          <a:ext cx="0" cy="0"/>
+          <a:chOff x="0" y="0"/>
+          <a:chExt cx="0" cy="0"/>
+        </a:xfrm>
+      </p:grpSpPr>
+      <p:sp>
+        <p:nvSpPr>
+          <p:cNvPr id="2" name="Slide Image Placeholder 1"/>
+          <p:cNvSpPr>
+            <a:spLocks noGrp="1"/>
+          </p:cNvSpPr>
+          <p:nvPr>
+            <p:ph type="sldImg" idx="2"/>
+          </p:nvPr>
+        </p:nvSpPr>
+        <p:spPr/>
+      </p:sp>
+      <p:sp>
+        <p:nvSpPr>
+          <p:cNvPr id="3" name="Notes Placeholder 2"/>
+          <p:cNvSpPr>
+            <a:spLocks noGrp="1"/>
+          </p:cNvSpPr>
+          <p:nvPr>
+            <p:ph type="body" idx="3" sz="quarter"/>
+          </p:nvPr>
+        </p:nvSpPr>
+        <p:spPr/>
+        <p:txBody>
+          <a:bodyPr/>
+          <a:lstStyle/>
+          <a:p>
+            <a:r>
+              <a:t>Connect. Guide link.</a:t>
+            </a:r>
+          </a:p>
+          <a:p>
+            <a:r>
+              <a:t>Questions.</a:t>
+            </a:r>
+          </a:p>
+        </p:txBody>
+      </p:sp>
+      <p:sp>
+        <p:nvSpPr>
+          <p:cNvPr id="4" name="Slide Number Placeholder 3"/>
+          <p:cNvSpPr>
+            <a:spLocks noGrp="1"/>
+          </p:cNvSpPr>
+          <p:nvPr>
+            <p:ph type="sldNum" idx="5" sz="quarter"/>
+          </p:nvPr>
+        </p:nvSpPr>
+        <p:spPr/>
+      </p:sp>
+    </p:spTree>
+  </p:cSld>
+  <p:clrMapOvr>
+    <a:masterClrMapping/>
+  </p:clrMapOvr>
+</p:notes>
+</file>
+
+<file path=ppt/notesSlides/notesSlide2.xml><?xml version="1.0" encoding="utf-8"?>
+<p:notes xmlns:a="http://schemas.openxmlformats.org/drawingml/2006/main" xmlns:p="http://schemas.openxmlformats.org/presentationml/2006/main" xmlns:r="http://schemas.openxmlformats.org/officeDocument/2006/relationships">
+  <p:cSld>
+    <p:spTree>
+      <p:nvGrpSpPr>
+        <p:cNvPr id="1" name=""/>
+        <p:cNvGrpSpPr/>
+        <p:nvPr/>
+      </p:nvGrpSpPr>
+      <p:grpSpPr>
+        <a:xfrm>
+          <a:off x="0" y="0"/>
+          <a:ext cx="0" cy="0"/>
+          <a:chOff x="0" y="0"/>
+          <a:chExt cx="0" cy="0"/>
+        </a:xfrm>
+      </p:grpSpPr>
+      <p:sp>
+        <p:nvSpPr>
+          <p:cNvPr id="2" name="Slide Image Placeholder 1"/>
+          <p:cNvSpPr>
+            <a:spLocks noGrp="1"/>
+          </p:cNvSpPr>
+          <p:nvPr>
+            <p:ph type="sldImg" idx="2"/>
+          </p:nvPr>
+        </p:nvSpPr>
+        <p:spPr/>
+      </p:sp>
+      <p:sp>
+        <p:nvSpPr>
+          <p:cNvPr id="3" name="Notes Placeholder 2"/>
+          <p:cNvSpPr>
+            <a:spLocks noGrp="1"/>
+          </p:cNvSpPr>
+          <p:nvPr>
+            <p:ph type="body" idx="3" sz="quarter"/>
+          </p:nvPr>
+        </p:nvSpPr>
+        <p:spPr/>
+        <p:txBody>
+          <a:bodyPr/>
+          <a:lstStyle/>
+          <a:p>
+            <a:r>
+              <a:t>Three steps.</a:t>
+            </a:r>
+          </a:p>
+          <a:p>
+            <a:r>
+              <a:t>Only requirement: MFA + login.</a:t>
+            </a:r>
+          </a:p>
+          <a:p>
+            <a:r>
+              <a:t>Then: switch to guide page for MFA.</a:t>
+            </a:r>
+          </a:p>
+        </p:txBody>
+      </p:sp>
+      <p:sp>
+        <p:nvSpPr>
+          <p:cNvPr id="4" name="Slide Number Placeholder 3"/>
+          <p:cNvSpPr>
+            <a:spLocks noGrp="1"/>
+          </p:cNvSpPr>
+          <p:nvPr>
+            <p:ph type="sldNum" idx="5" sz="quarter"/>
+          </p:nvPr>
+        </p:nvSpPr>
+        <p:spPr/>
+      </p:sp>
+    </p:spTree>
+  </p:cSld>
+  <p:clrMapOvr>
+    <a:masterClrMapping/>
+  </p:clrMapOvr>
+</p:notes>
+</file>
+
+<file path=ppt/notesSlides/notesSlide3.xml><?xml version="1.0" encoding="utf-8"?>
+<p:notes xmlns:a="http://schemas.openxmlformats.org/drawingml/2006/main" xmlns:p="http://schemas.openxmlformats.org/presentationml/2006/main" xmlns:r="http://schemas.openxmlformats.org/officeDocument/2006/relationships">
+  <p:cSld>
+    <p:spTree>
+      <p:nvGrpSpPr>
+        <p:cNvPr id="1" name=""/>
+        <p:cNvGrpSpPr/>
+        <p:nvPr/>
+      </p:nvGrpSpPr>
+      <p:grpSpPr>
+        <a:xfrm>
+          <a:off x="0" y="0"/>
+          <a:ext cx="0" cy="0"/>
+          <a:chOff x="0" y="0"/>
+          <a:chExt cx="0" cy="0"/>
+        </a:xfrm>
+      </p:grpSpPr>
+      <p:sp>
+        <p:nvSpPr>
+          <p:cNvPr id="2" name="Slide Image Placeholder 1"/>
+          <p:cNvSpPr>
+            <a:spLocks noGrp="1"/>
+          </p:cNvSpPr>
+          <p:nvPr>
+            <p:ph type="sldImg" idx="2"/>
+          </p:nvPr>
+        </p:nvSpPr>
+        <p:spPr/>
+      </p:sp>
+      <p:sp>
+        <p:nvSpPr>
+          <p:cNvPr id="3" name="Notes Placeholder 2"/>
+          <p:cNvSpPr>
+            <a:spLocks noGrp="1"/>
+          </p:cNvSpPr>
+          <p:nvPr>
+            <p:ph type="body" idx="3" sz="quarter"/>
+          </p:nvPr>
+        </p:nvSpPr>
+        <p:spPr/>
+        <p:txBody>
+          <a:bodyPr/>
+          <a:lstStyle/>
+          <a:p>
+            <a:r>
+              <a:t>Stragglers keep working on MFA.</a:t>
+            </a:r>
+          </a:p>
+          <a:p>
+            <a:r>
+              <a:t>National resource, shared.</a:t>
+            </a:r>
+          </a:p>
+          <a:p>
+            <a:r>
+              <a:t>Nodes = computers working together.</a:t>
+            </a:r>
+          </a:p>
+        </p:txBody>
+      </p:sp>
+      <p:sp>
+        <p:nvSpPr>
+          <p:cNvPr id="4" name="Slide Number Placeholder 3"/>
+          <p:cNvSpPr>
+            <a:spLocks noGrp="1"/>
+          </p:cNvSpPr>
+          <p:nvPr>
+            <p:ph type="sldNum" idx="5" sz="quarter"/>
+          </p:nvPr>
+        </p:nvSpPr>
+        <p:spPr/>
+      </p:sp>
+    </p:spTree>
+  </p:cSld>
+  <p:clrMapOvr>
+    <a:masterClrMapping/>
+  </p:clrMapOvr>
+</p:notes>
+</file>
+
+<file path=ppt/notesSlides/notesSlide4.xml><?xml version="1.0" encoding="utf-8"?>
+<p:notes xmlns:a="http://schemas.openxmlformats.org/drawingml/2006/main" xmlns:p="http://schemas.openxmlformats.org/presentationml/2006/main" xmlns:r="http://schemas.openxmlformats.org/officeDocument/2006/relationships">
+  <p:cSld>
+    <p:spTree>
+      <p:nvGrpSpPr>
+        <p:cNvPr id="1" name=""/>
+        <p:cNvGrpSpPr/>
+        <p:nvPr/>
+      </p:nvGrpSpPr>
+      <p:grpSpPr>
+        <a:xfrm>
+          <a:off x="0" y="0"/>
+          <a:ext cx="0" cy="0"/>
+          <a:chOff x="0" y="0"/>
+          <a:chExt cx="0" cy="0"/>
+        </a:xfrm>
+      </p:grpSpPr>
+      <p:sp>
+        <p:nvSpPr>
+          <p:cNvPr id="2" name="Slide Image Placeholder 1"/>
+          <p:cNvSpPr>
+            <a:spLocks noGrp="1"/>
+          </p:cNvSpPr>
+          <p:nvPr>
+            <p:ph type="sldImg" idx="2"/>
+          </p:nvPr>
+        </p:nvSpPr>
+        <p:spPr/>
+      </p:sp>
+      <p:sp>
+        <p:nvSpPr>
+          <p:cNvPr id="3" name="Notes Placeholder 2"/>
+          <p:cNvSpPr>
+            <a:spLocks noGrp="1"/>
+          </p:cNvSpPr>
+          <p:nvPr>
+            <p:ph type="body" idx="3" sz="quarter"/>
+          </p:nvPr>
+        </p:nvSpPr>
+        <p:spPr/>
+        <p:txBody>
+          <a:bodyPr/>
+          <a:lstStyle/>
+          <a:p>
+            <a:r>
+              <a:t>Same account, same login.</a:t>
+            </a:r>
+          </a:p>
+          <a:p>
+            <a:r>
+              <a:t>Vista tonight.</a:t>
+            </a:r>
+          </a:p>
+        </p:txBody>
+      </p:sp>
+      <p:sp>
+        <p:nvSpPr>
+          <p:cNvPr id="4" name="Slide Number Placeholder 3"/>
+          <p:cNvSpPr>
+            <a:spLocks noGrp="1"/>
+          </p:cNvSpPr>
+          <p:nvPr>
+            <p:ph type="sldNum" idx="5" sz="quarter"/>
+          </p:nvPr>
+        </p:nvSpPr>
+        <p:spPr/>
+      </p:sp>
+    </p:spTree>
+  </p:cSld>
+  <p:clrMapOvr>
+    <a:masterClrMapping/>
+  </p:clrMapOvr>
+</p:notes>
+</file>
+
+<file path=ppt/notesSlides/notesSlide5.xml><?xml version="1.0" encoding="utf-8"?>
+<p:notes xmlns:a="http://schemas.openxmlformats.org/drawingml/2006/main" xmlns:p="http://schemas.openxmlformats.org/presentationml/2006/main" xmlns:r="http://schemas.openxmlformats.org/officeDocument/2006/relationships">
+  <p:cSld>
+    <p:spTree>
+      <p:nvGrpSpPr>
+        <p:cNvPr id="1" name=""/>
+        <p:cNvGrpSpPr/>
+        <p:nvPr/>
+      </p:nvGrpSpPr>
+      <p:grpSpPr>
+        <a:xfrm>
+          <a:off x="0" y="0"/>
+          <a:ext cx="0" cy="0"/>
+          <a:chOff x="0" y="0"/>
+          <a:chExt cx="0" cy="0"/>
+        </a:xfrm>
+      </p:grpSpPr>
+      <p:sp>
+        <p:nvSpPr>
+          <p:cNvPr id="2" name="Slide Image Placeholder 1"/>
+          <p:cNvSpPr>
+            <a:spLocks noGrp="1"/>
+          </p:cNvSpPr>
+          <p:nvPr>
+            <p:ph type="sldImg" idx="2"/>
+          </p:nvPr>
+        </p:nvSpPr>
+        <p:spPr/>
+      </p:sp>
+      <p:sp>
+        <p:nvSpPr>
+          <p:cNvPr id="3" name="Notes Placeholder 2"/>
+          <p:cNvSpPr>
+            <a:spLocks noGrp="1"/>
+          </p:cNvSpPr>
+          <p:nvPr>
+            <p:ph type="body" idx="3" sz="quarter"/>
+          </p:nvPr>
+        </p:nvSpPr>
+        <p:spPr/>
+        <p:txBody>
+          <a:bodyPr/>
+          <a:lstStyle/>
+          <a:p>
+            <a:r>
+              <a:t>Too big, too slow, too many.</a:t>
+            </a:r>
+          </a:p>
+          <a:p>
+            <a:r>
+              <a:t>Card 4: learning counts.</a:t>
+            </a:r>
+          </a:p>
+        </p:txBody>
+      </p:sp>
+      <p:sp>
+        <p:nvSpPr>
+          <p:cNvPr id="4" name="Slide Number Placeholder 3"/>
+          <p:cNvSpPr>
+            <a:spLocks noGrp="1"/>
+          </p:cNvSpPr>
+          <p:nvPr>
+            <p:ph type="sldNum" idx="5" sz="quarter"/>
+          </p:nvPr>
+        </p:nvSpPr>
+        <p:spPr/>
+      </p:sp>
+    </p:spTree>
+  </p:cSld>
+  <p:clrMapOvr>
+    <a:masterClrMapping/>
+  </p:clrMapOvr>
+</p:notes>
+</file>
+
+<file path=ppt/notesSlides/notesSlide6.xml><?xml version="1.0" encoding="utf-8"?>
+<p:notes xmlns:a="http://schemas.openxmlformats.org/drawingml/2006/main" xmlns:p="http://schemas.openxmlformats.org/presentationml/2006/main" xmlns:r="http://schemas.openxmlformats.org/officeDocument/2006/relationships">
+  <p:cSld>
+    <p:spTree>
+      <p:nvGrpSpPr>
+        <p:cNvPr id="1" name=""/>
+        <p:cNvGrpSpPr/>
+        <p:nvPr/>
+      </p:nvGrpSpPr>
+      <p:grpSpPr>
+        <a:xfrm>
+          <a:off x="0" y="0"/>
+          <a:ext cx="0" cy="0"/>
+          <a:chOff x="0" y="0"/>
+          <a:chExt cx="0" cy="0"/>
+        </a:xfrm>
+      </p:grpSpPr>
+      <p:sp>
+        <p:nvSpPr>
+          <p:cNvPr id="2" name="Slide Image Placeholder 1"/>
+          <p:cNvSpPr>
+            <a:spLocks noGrp="1"/>
+          </p:cNvSpPr>
+          <p:nvPr>
+            <p:ph type="sldImg" idx="2"/>
+          </p:nvPr>
+        </p:nvSpPr>
+        <p:spPr/>
+      </p:sp>
+      <p:sp>
+        <p:nvSpPr>
+          <p:cNvPr id="3" name="Notes Placeholder 2"/>
+          <p:cNvSpPr>
+            <a:spLocks noGrp="1"/>
+          </p:cNvSpPr>
+          <p:nvPr>
+            <p:ph type="body" idx="3" sz="quarter"/>
+          </p:nvPr>
+        </p:nvSpPr>
+        <p:spPr/>
+        <p:txBody>
+          <a:bodyPr/>
+          <a:lstStyle/>
+          <a:p>
+            <a:r>
+              <a:t>Shared machine = rules.</a:t>
+            </a:r>
+          </a:p>
+        </p:txBody>
+      </p:sp>
+      <p:sp>
+        <p:nvSpPr>
+          <p:cNvPr id="4" name="Slide Number Placeholder 3"/>
+          <p:cNvSpPr>
+            <a:spLocks noGrp="1"/>
+          </p:cNvSpPr>
+          <p:nvPr>
+            <p:ph type="sldNum" idx="5" sz="quarter"/>
+          </p:nvPr>
+        </p:nvSpPr>
+        <p:spPr/>
+      </p:sp>
+    </p:spTree>
+  </p:cSld>
+  <p:clrMapOvr>
+    <a:masterClrMapping/>
+  </p:clrMapOvr>
+</p:notes>
+</file>
+
+<file path=ppt/notesSlides/notesSlide7.xml><?xml version="1.0" encoding="utf-8"?>
+<p:notes xmlns:a="http://schemas.openxmlformats.org/drawingml/2006/main" xmlns:p="http://schemas.openxmlformats.org/presentationml/2006/main" xmlns:r="http://schemas.openxmlformats.org/officeDocument/2006/relationships">
+  <p:cSld>
+    <p:spTree>
+      <p:nvGrpSpPr>
+        <p:cNvPr id="1" name=""/>
+        <p:cNvGrpSpPr/>
+        <p:nvPr/>
+      </p:nvGrpSpPr>
+      <p:grpSpPr>
+        <a:xfrm>
+          <a:off x="0" y="0"/>
+          <a:ext cx="0" cy="0"/>
+          <a:chOff x="0" y="0"/>
+          <a:chExt cx="0" cy="0"/>
+        </a:xfrm>
+      </p:grpSpPr>
+      <p:sp>
+        <p:nvSpPr>
+          <p:cNvPr id="2" name="Slide Image Placeholder 1"/>
+          <p:cNvSpPr>
+            <a:spLocks noGrp="1"/>
+          </p:cNvSpPr>
+          <p:nvPr>
+            <p:ph type="sldImg" idx="2"/>
+          </p:nvPr>
+        </p:nvSpPr>
+        <p:spPr/>
+      </p:sp>
+      <p:sp>
+        <p:nvSpPr>
+          <p:cNvPr id="3" name="Notes Placeholder 2"/>
+          <p:cNvSpPr>
+            <a:spLocks noGrp="1"/>
+          </p:cNvSpPr>
+          <p:nvPr>
+            <p:ph type="body" idx="3" sz="quarter"/>
+          </p:nvPr>
+        </p:nvSpPr>
+        <p:spPr/>
+        <p:txBody>
+          <a:bodyPr/>
+          <a:lstStyle/>
+          <a:p>
+            <a:r>
+              <a:t>Core = one worker.</a:t>
+            </a:r>
+          </a:p>
+          <a:p>
+            <a:r>
+              <a:t>Node = 144 cores (72 on GPU nodes).</a:t>
+            </a:r>
+          </a:p>
+          <a:p>
+            <a:r>
+              <a:t>Vista = 856 nodes, 80,064 cores.</a:t>
+            </a:r>
+          </a:p>
+        </p:txBody>
+      </p:sp>
+      <p:sp>
+        <p:nvSpPr>
+          <p:cNvPr id="4" name="Slide Number Placeholder 3"/>
+          <p:cNvSpPr>
+            <a:spLocks noGrp="1"/>
+          </p:cNvSpPr>
+          <p:nvPr>
+            <p:ph type="sldNum" idx="5" sz="quarter"/>
+          </p:nvPr>
+        </p:nvSpPr>
+        <p:spPr/>
+      </p:sp>
+    </p:spTree>
+  </p:cSld>
+  <p:clrMapOvr>
+    <a:masterClrMapping/>
+  </p:clrMapOvr>
+</p:notes>
+</file>
+
+<file path=ppt/notesSlides/notesSlide8.xml><?xml version="1.0" encoding="utf-8"?>
+<p:notes xmlns:a="http://schemas.openxmlformats.org/drawingml/2006/main" xmlns:p="http://schemas.openxmlformats.org/presentationml/2006/main" xmlns:r="http://schemas.openxmlformats.org/officeDocument/2006/relationships">
+  <p:cSld>
+    <p:spTree>
+      <p:nvGrpSpPr>
+        <p:cNvPr id="1" name=""/>
+        <p:cNvGrpSpPr/>
+        <p:nvPr/>
+      </p:nvGrpSpPr>
+      <p:grpSpPr>
+        <a:xfrm>
+          <a:off x="0" y="0"/>
+          <a:ext cx="0" cy="0"/>
+          <a:chOff x="0" y="0"/>
+          <a:chExt cx="0" cy="0"/>
+        </a:xfrm>
+      </p:grpSpPr>
+      <p:sp>
+        <p:nvSpPr>
+          <p:cNvPr id="2" name="Slide Image Placeholder 1"/>
+          <p:cNvSpPr>
+            <a:spLocks noGrp="1"/>
+          </p:cNvSpPr>
+          <p:nvPr>
+            <p:ph type="sldImg" idx="2"/>
+          </p:nvPr>
+        </p:nvSpPr>
+        <p:spPr/>
+      </p:sp>
+      <p:sp>
+        <p:nvSpPr>
+          <p:cNvPr id="3" name="Notes Placeholder 2"/>
+          <p:cNvSpPr>
+            <a:spLocks noGrp="1"/>
+          </p:cNvSpPr>
+          <p:nvPr>
+            <p:ph type="body" idx="3" sz="quarter"/>
+          </p:nvPr>
+        </p:nvSpPr>
+        <p:spPr/>
+        <p:txBody>
+          <a:bodyPr/>
+          <a:lstStyle/>
+          <a:p>
+            <a:r>
+              <a:t>Login node = lobby. Shared.</a:t>
+            </a:r>
+          </a:p>
+          <a:p>
+            <a:r>
+              <a:t>Compute = labs.</a:t>
+            </a:r>
+          </a:p>
+          <a:p>
+            <a:r>
+              <a:t>Sets up rule 1.</a:t>
+            </a:r>
+          </a:p>
+        </p:txBody>
+      </p:sp>
+      <p:sp>
+        <p:nvSpPr>
+          <p:cNvPr id="4" name="Slide Number Placeholder 3"/>
+          <p:cNvSpPr>
+            <a:spLocks noGrp="1"/>
+          </p:cNvSpPr>
+          <p:nvPr>
+            <p:ph type="sldNum" idx="5" sz="quarter"/>
+          </p:nvPr>
+        </p:nvSpPr>
+        <p:spPr/>
+      </p:sp>
+    </p:spTree>
+  </p:cSld>
+  <p:clrMapOvr>
+    <a:masterClrMapping/>
+  </p:clrMapOvr>
+</p:notes>
+</file>
+
+<file path=ppt/notesSlides/notesSlide9.xml><?xml version="1.0" encoding="utf-8"?>
+<p:notes xmlns:a="http://schemas.openxmlformats.org/drawingml/2006/main" xmlns:p="http://schemas.openxmlformats.org/presentationml/2006/main" xmlns:r="http://schemas.openxmlformats.org/officeDocument/2006/relationships">
+  <p:cSld>
+    <p:spTree>
+      <p:nvGrpSpPr>
+        <p:cNvPr id="1" name=""/>
+        <p:cNvGrpSpPr/>
+        <p:nvPr/>
+      </p:nvGrpSpPr>
+      <p:grpSpPr>
+        <a:xfrm>
+          <a:off x="0" y="0"/>
+          <a:ext cx="0" cy="0"/>
+          <a:chOff x="0" y="0"/>
+          <a:chExt cx="0" cy="0"/>
+        </a:xfrm>
+      </p:grpSpPr>
+      <p:sp>
+        <p:nvSpPr>
+          <p:cNvPr id="2" name="Slide Image Placeholder 1"/>
+          <p:cNvSpPr>
+            <a:spLocks noGrp="1"/>
+          </p:cNvSpPr>
+          <p:nvPr>
+            <p:ph type="sldImg" idx="2"/>
+          </p:nvPr>
+        </p:nvSpPr>
+        <p:spPr/>
+      </p:sp>
+      <p:sp>
+        <p:nvSpPr>
+          <p:cNvPr id="3" name="Notes Placeholder 2"/>
+          <p:cNvSpPr>
+            <a:spLocks noGrp="1"/>
+          </p:cNvSpPr>
+          <p:nvPr>
+            <p:ph type="body" idx="3" sz="quarter"/>
+          </p:nvPr>
+        </p:nvSpPr>
+        <p:spPr/>
+        <p:txBody>
+          <a:bodyPr/>
+          <a:lstStyle/>
+          <a:p>
+            <a:r>
+              <a:t>HOME small, backed up.</a:t>
+            </a:r>
+          </a:p>
+          <a:p>
+            <a:r>
+              <a:t>WORK = your projects.</a:t>
+            </a:r>
+          </a:p>
+          <a:p>
+            <a:r>
+              <a:t>SCRATCH = temporary, 10 days.</a:t>
+            </a:r>
+          </a:p>
+          <a:p>
+            <a:r>
+              <a:t>These are the folders you'll see in Tapis.</a:t>
+            </a:r>
+          </a:p>
+        </p:txBody>
+      </p:sp>
+      <p:sp>
+        <p:nvSpPr>
+          <p:cNvPr id="4" name="Slide Number Placeholder 3"/>
+          <p:cNvSpPr>
+            <a:spLocks noGrp="1"/>
+          </p:cNvSpPr>
+          <p:nvPr>
+            <p:ph type="sldNum" idx="5" sz="quarter"/>
+          </p:nvPr>
+        </p:nvSpPr>
+        <p:spPr/>
+      </p:sp>
+    </p:spTree>
+  </p:cSld>
+  <p:clrMapOvr>
+    <a:masterClrMapping/>
+  </p:clrMapOvr>
+</p:notes>
 </file>
 
 <file path=ppt/slideLayouts/slideLayout1.xml><?xml version="1.0" encoding="utf-8"?>
@@ -12813,4 +14183,324 @@
   </a:objectDefaults>
   <a:extraClrSchemeLst/>
 </a:theme>
+</file>
+
+<file path=ppt/theme/theme2.xml><?xml version="1.0" encoding="utf-8"?>
+<a:theme xmlns:a="http://schemas.openxmlformats.org/drawingml/2006/main" name="Office Theme">
+  <a:themeElements>
+    <a:clrScheme name="Office">
+      <a:dk1>
+        <a:sysClr val="windowText" lastClr="000000"/>
+      </a:dk1>
+      <a:lt1>
+        <a:sysClr val="window" lastClr="FFFFFF"/>
+      </a:lt1>
+      <a:dk2>
+        <a:srgbClr val="1F497D"/>
+      </a:dk2>
+      <a:lt2>
+        <a:srgbClr val="EEECE1"/>
+      </a:lt2>
+      <a:accent1>
+        <a:srgbClr val="4F81BD"/>
+      </a:accent1>
+      <a:accent2>
+        <a:srgbClr val="C0504D"/>
+      </a:accent2>
+      <a:accent3>
+        <a:srgbClr val="9BBB59"/>
+      </a:accent3>
+      <a:accent4>
+        <a:srgbClr val="8064A2"/>
+      </a:accent4>
+      <a:accent5>
+        <a:srgbClr val="4BACC6"/>
+      </a:accent5>
+      <a:accent6>
+        <a:srgbClr val="F79646"/>
+      </a:accent6>
+      <a:hlink>
+        <a:srgbClr val="0000FF"/>
+      </a:hlink>
+      <a:folHlink>
+        <a:srgbClr val="800080"/>
+      </a:folHlink>
+    </a:clrScheme>
+    <a:fontScheme name="Office">
+      <a:majorFont>
+        <a:latin typeface="Calibri"/>
+        <a:ea typeface=""/>
+        <a:cs typeface=""/>
+        <a:font script="Jpan" typeface="ＭＳ Ｐゴシック"/>
+        <a:font script="Hang" typeface="맑은 고딕"/>
+        <a:font script="Hans" typeface="宋体"/>
+        <a:font script="Hant" typeface="新細明體"/>
+        <a:font script="Arab" typeface="Times New Roman"/>
+        <a:font script="Hebr" typeface="Times New Roman"/>
+        <a:font script="Thai" typeface="Angsana New"/>
+        <a:font script="Ethi" typeface="Nyala"/>
+        <a:font script="Beng" typeface="Vrinda"/>
+        <a:font script="Gujr" typeface="Shruti"/>
+        <a:font script="Khmr" typeface="MoolBoran"/>
+        <a:font script="Knda" typeface="Tunga"/>
+        <a:font script="Guru" typeface="Raavi"/>
+        <a:font script="Cans" typeface="Euphemia"/>
+        <a:font script="Cher" typeface="Plantagenet Cherokee"/>
+        <a:font script="Yiii" typeface="Microsoft Yi Baiti"/>
+        <a:font script="Tibt" typeface="Microsoft Himalaya"/>
+        <a:font script="Thaa" typeface="MV Boli"/>
+        <a:font script="Deva" typeface="Mangal"/>
+        <a:font script="Telu" typeface="Gautami"/>
+        <a:font script="Taml" typeface="Latha"/>
+        <a:font script="Syrc" typeface="Estrangelo Edessa"/>
+        <a:font script="Orya" typeface="Kalinga"/>
+        <a:font script="Mlym" typeface="Kartika"/>
+        <a:font script="Laoo" typeface="DokChampa"/>
+        <a:font script="Sinh" typeface="Iskoola Pota"/>
+        <a:font script="Mong" typeface="Mongolian Baiti"/>
+        <a:font script="Viet" typeface="Times New Roman"/>
+        <a:font script="Uigh" typeface="Microsoft Uighur"/>
+        <a:font script="Geor" typeface="Sylfaen"/>
+      </a:majorFont>
+      <a:minorFont>
+        <a:latin typeface="Calibri"/>
+        <a:ea typeface=""/>
+        <a:cs typeface=""/>
+        <a:font script="Jpan" typeface="ＭＳ Ｐゴシック"/>
+        <a:font script="Hang" typeface="맑은 고딕"/>
+        <a:font script="Hans" typeface="宋体"/>
+        <a:font script="Hant" typeface="新細明體"/>
+        <a:font script="Arab" typeface="Arial"/>
+        <a:font script="Hebr" typeface="Arial"/>
+        <a:font script="Thai" typeface="Cordia New"/>
+        <a:font script="Ethi" typeface="Nyala"/>
+        <a:font script="Beng" typeface="Vrinda"/>
+        <a:font script="Gujr" typeface="Shruti"/>
+        <a:font script="Khmr" typeface="DaunPenh"/>
+        <a:font script="Knda" typeface="Tunga"/>
+        <a:font script="Guru" typeface="Raavi"/>
+        <a:font script="Cans" typeface="Euphemia"/>
+        <a:font script="Cher" typeface="Plantagenet Cherokee"/>
+        <a:font script="Yiii" typeface="Microsoft Yi Baiti"/>
+        <a:font script="Tibt" typeface="Microsoft Himalaya"/>
+        <a:font script="Thaa" typeface="MV Boli"/>
+        <a:font script="Deva" typeface="Mangal"/>
+        <a:font script="Telu" typeface="Gautami"/>
+        <a:font script="Taml" typeface="Latha"/>
+        <a:font script="Syrc" typeface="Estrangelo Edessa"/>
+        <a:font script="Orya" typeface="Kalinga"/>
+        <a:font script="Mlym" typeface="Kartika"/>
+        <a:font script="Laoo" typeface="DokChampa"/>
+        <a:font script="Sinh" typeface="Iskoola Pota"/>
+        <a:font script="Mong" typeface="Mongolian Baiti"/>
+        <a:font script="Viet" typeface="Arial"/>
+        <a:font script="Uigh" typeface="Microsoft Uighur"/>
+        <a:font script="Geor" typeface="Sylfaen"/>
+      </a:minorFont>
+    </a:fontScheme>
+    <a:fmtScheme name="Office">
+      <a:fillStyleLst>
+        <a:solidFill>
+          <a:schemeClr val="phClr"/>
+        </a:solidFill>
+        <a:gradFill rotWithShape="1">
+          <a:gsLst>
+            <a:gs pos="0">
+              <a:schemeClr val="phClr">
+                <a:tint val="50000"/>
+                <a:satMod val="300000"/>
+              </a:schemeClr>
+            </a:gs>
+            <a:gs pos="35000">
+              <a:schemeClr val="phClr">
+                <a:tint val="37000"/>
+                <a:satMod val="300000"/>
+              </a:schemeClr>
+            </a:gs>
+            <a:gs pos="100000">
+              <a:schemeClr val="phClr">
+                <a:tint val="15000"/>
+                <a:satMod val="350000"/>
+              </a:schemeClr>
+            </a:gs>
+          </a:gsLst>
+          <a:lin ang="16200000" scaled="1"/>
+        </a:gradFill>
+        <a:gradFill rotWithShape="1">
+          <a:gsLst>
+            <a:gs pos="0">
+              <a:schemeClr val="phClr">
+                <a:tint val="100000"/>
+                <a:shade val="100000"/>
+                <a:satMod val="130000"/>
+              </a:schemeClr>
+            </a:gs>
+            <a:gs pos="100000">
+              <a:schemeClr val="phClr">
+                <a:tint val="50000"/>
+                <a:shade val="100000"/>
+                <a:satMod val="350000"/>
+              </a:schemeClr>
+            </a:gs>
+          </a:gsLst>
+          <a:lin ang="16200000" scaled="0"/>
+        </a:gradFill>
+      </a:fillStyleLst>
+      <a:lnStyleLst>
+        <a:ln w="9525" cap="flat" cmpd="sng" algn="ctr">
+          <a:solidFill>
+            <a:schemeClr val="phClr">
+              <a:shade val="95000"/>
+              <a:satMod val="105000"/>
+            </a:schemeClr>
+          </a:solidFill>
+          <a:prstDash val="solid"/>
+        </a:ln>
+        <a:ln w="25400" cap="flat" cmpd="sng" algn="ctr">
+          <a:solidFill>
+            <a:schemeClr val="phClr"/>
+          </a:solidFill>
+          <a:prstDash val="solid"/>
+        </a:ln>
+        <a:ln w="38100" cap="flat" cmpd="sng" algn="ctr">
+          <a:solidFill>
+            <a:schemeClr val="phClr"/>
+          </a:solidFill>
+          <a:prstDash val="solid"/>
+        </a:ln>
+      </a:lnStyleLst>
+      <a:effectStyleLst>
+        <a:effectStyle>
+          <a:effectLst>
+            <a:outerShdw blurRad="40000" dist="20000" dir="5400000" rotWithShape="0">
+              <a:srgbClr val="000000">
+                <a:alpha val="38000"/>
+              </a:srgbClr>
+            </a:outerShdw>
+          </a:effectLst>
+        </a:effectStyle>
+        <a:effectStyle>
+          <a:effectLst>
+            <a:outerShdw blurRad="40000" dist="23000" dir="5400000" rotWithShape="0">
+              <a:srgbClr val="000000">
+                <a:alpha val="35000"/>
+              </a:srgbClr>
+            </a:outerShdw>
+          </a:effectLst>
+        </a:effectStyle>
+        <a:effectStyle>
+          <a:effectLst>
+            <a:outerShdw blurRad="40000" dist="23000" dir="5400000" rotWithShape="0">
+              <a:srgbClr val="000000">
+                <a:alpha val="35000"/>
+              </a:srgbClr>
+            </a:outerShdw>
+          </a:effectLst>
+          <a:scene3d>
+            <a:camera prst="orthographicFront">
+              <a:rot lat="0" lon="0" rev="0"/>
+            </a:camera>
+            <a:lightRig rig="threePt" dir="t">
+              <a:rot lat="0" lon="0" rev="1200000"/>
+            </a:lightRig>
+          </a:scene3d>
+          <a:sp3d>
+            <a:bevelT w="63500" h="25400"/>
+          </a:sp3d>
+        </a:effectStyle>
+      </a:effectStyleLst>
+      <a:bgFillStyleLst>
+        <a:solidFill>
+          <a:schemeClr val="phClr"/>
+        </a:solidFill>
+        <a:gradFill rotWithShape="1">
+          <a:gsLst>
+            <a:gs pos="0">
+              <a:schemeClr val="phClr">
+                <a:tint val="40000"/>
+                <a:satMod val="350000"/>
+              </a:schemeClr>
+            </a:gs>
+            <a:gs pos="40000">
+              <a:schemeClr val="phClr">
+                <a:tint val="45000"/>
+                <a:shade val="99000"/>
+                <a:satMod val="350000"/>
+              </a:schemeClr>
+            </a:gs>
+            <a:gs pos="100000">
+              <a:schemeClr val="phClr">
+                <a:shade val="20000"/>
+                <a:satMod val="255000"/>
+              </a:schemeClr>
+            </a:gs>
+          </a:gsLst>
+          <a:path path="circle">
+            <a:fillToRect l="50000" t="-80000" r="50000" b="180000"/>
+          </a:path>
+        </a:gradFill>
+        <a:gradFill rotWithShape="1">
+          <a:gsLst>
+            <a:gs pos="0">
+              <a:schemeClr val="phClr">
+                <a:tint val="80000"/>
+                <a:satMod val="300000"/>
+              </a:schemeClr>
+            </a:gs>
+            <a:gs pos="100000">
+              <a:schemeClr val="phClr">
+                <a:shade val="30000"/>
+                <a:satMod val="200000"/>
+              </a:schemeClr>
+            </a:gs>
+          </a:gsLst>
+          <a:path path="circle">
+            <a:fillToRect l="50000" t="50000" r="50000" b="50000"/>
+          </a:path>
+        </a:gradFill>
+      </a:bgFillStyleLst>
+    </a:fmtScheme>
+  </a:themeElements>
+  <a:objectDefaults>
+    <a:spDef>
+      <a:spPr/>
+      <a:bodyPr/>
+      <a:lstStyle/>
+      <a:style>
+        <a:lnRef idx="1">
+          <a:schemeClr val="accent1"/>
+        </a:lnRef>
+        <a:fillRef idx="3">
+          <a:schemeClr val="accent1"/>
+        </a:fillRef>
+        <a:effectRef idx="2">
+          <a:schemeClr val="accent1"/>
+        </a:effectRef>
+        <a:fontRef idx="minor">
+          <a:schemeClr val="lt1"/>
+        </a:fontRef>
+      </a:style>
+    </a:spDef>
+    <a:lnDef>
+      <a:spPr/>
+      <a:bodyPr/>
+      <a:lstStyle/>
+      <a:style>
+        <a:lnRef idx="2">
+          <a:schemeClr val="accent1"/>
+        </a:lnRef>
+        <a:fillRef idx="0">
+          <a:schemeClr val="accent1"/>
+        </a:fillRef>
+        <a:effectRef idx="1">
+          <a:schemeClr val="accent1"/>
+        </a:effectRef>
+        <a:fontRef idx="minor">
+          <a:schemeClr val="tx1"/>
+        </a:fontRef>
+      </a:style>
+    </a:lnDef>
+  </a:objectDefaults>
+  <a:extraClrSchemeLst/>
+</a:theme>
 </file>
</xml_diff>

<commit_message>
Expand slide 12 speaker notes
</commit_message>
<xml_diff>
--- a/slides/hpc-office-hours.pptx
+++ b/slides/hpc-office-hours.pptx
@@ -749,22 +749,27 @@
           <a:lstStyle/>
           <a:p>
             <a:r>
-              <a:t>CFPB complaints, ~10M.</a:t>
-            </a:r>
-          </a:p>
-          <a:p>
-            <a:r>
-              <a:t>Oct 14: three numbers for the Canvas.</a:t>
-            </a:r>
-          </a:p>
-          <a:p>
-            <a:r>
-              <a:t>Nov 4: the pain point.</a:t>
-            </a:r>
-          </a:p>
-          <a:p>
-            <a:r>
-              <a:t>Fall evidence = spring prototype.</a:t>
+              <a:t>CFPB = Consumer Financial Protection Bureau. Free public complaint database, ~10M complaints about money transfers, prepaid cards, digital payments. Too big for a laptop.</a:t>
+            </a:r>
+          </a:p>
+          <a:p>
+            <a:r>
+              <a:t>Ready-made notebook: change one cell (sector, state), rerun. No coding.</a:t>
+            </a:r>
+          </a:p>
+          <a:p>
+            <a:r>
+              <a:t>Oct 14: counts by product, company, state, year. Three numbers for the Monetization Canvas (due Oct 23).</a:t>
+            </a:r>
+          </a:p>
+          <a:p>
+            <a:r>
+              <a:t>Nov 4: read the complaint text at scale. Theme closest to your business problem. Feeds Nov 13 business model and Dec 4 pitch.</a:t>
+            </a:r>
+          </a:p>
+          <a:p>
+            <a:r>
+              <a:t>OPIL: "this many people said so." Fall pain points = spring prototype requirements.</a:t>
             </a:r>
           </a:p>
         </p:txBody>

</xml_diff>